<commit_message>
Add pink/blue gender accents to the brown deck
Female = muted rose, male = denim blue, applied to gender glyphs, the
scales-of-fairness motif, and the résumé accents — layered into the warm
brown palette while eyebrows/semantic accents stay brown.

Co-Authored-By: Claude Opus 4.8 <noreply@anthropic.com>
Claude-Session: https://claude.ai/code/session_01CjyAZ3oyttzTdGPrNqWN3p
</commit_message>
<xml_diff>
--- a/presentation/gender_bias_llm_hiring.pptx
+++ b/presentation/gender_bias_llm_hiring.pptx
@@ -3288,7 +3288,7 @@
             <a:r>
               <a:rPr sz="6200" b="0" i="0">
                 <a:solidFill>
-                  <a:srgbClr val="B0563A"/>
+                  <a:srgbClr val="D6749C"/>
                 </a:solidFill>
                 <a:latin typeface="Calibri"/>
               </a:rPr>
@@ -3306,7 +3306,7 @@
             <a:r>
               <a:rPr sz="6200" b="0" i="0">
                 <a:solidFill>
-                  <a:srgbClr val="6B4A34"/>
+                  <a:srgbClr val="6E8FC0"/>
                 </a:solidFill>
                 <a:latin typeface="Calibri"/>
               </a:rPr>
@@ -3842,7 +3842,7 @@
             <a:r>
               <a:rPr sz="5800" b="0" i="0">
                 <a:solidFill>
-                  <a:srgbClr val="B0563A"/>
+                  <a:srgbClr val="D6749C"/>
                 </a:solidFill>
                 <a:latin typeface="Calibri"/>
               </a:rPr>
@@ -3860,7 +3860,7 @@
             <a:r>
               <a:rPr sz="5800" b="0" i="0">
                 <a:solidFill>
-                  <a:srgbClr val="6B4A34"/>
+                  <a:srgbClr val="6E8FC0"/>
                 </a:solidFill>
                 <a:latin typeface="Calibri"/>
               </a:rPr>
@@ -7051,7 +7051,7 @@
             <a:r>
               <a:rPr sz="4800" b="1" i="0">
                 <a:solidFill>
-                  <a:srgbClr val="6B4A34"/>
+                  <a:srgbClr val="6E8FC0"/>
                 </a:solidFill>
                 <a:latin typeface="Calibri"/>
               </a:rPr>
@@ -7178,7 +7178,7 @@
             <a:r>
               <a:rPr sz="4800" b="1" i="0">
                 <a:solidFill>
-                  <a:srgbClr val="B0563A"/>
+                  <a:srgbClr val="D6749C"/>
                 </a:solidFill>
                 <a:latin typeface="Calibri"/>
               </a:rPr>
@@ -7564,7 +7564,7 @@
             </a:avLst>
           </a:prstGeom>
           <a:solidFill>
-            <a:srgbClr val="B0563A"/>
+            <a:srgbClr val="D6749C"/>
           </a:solidFill>
           <a:ln>
             <a:noFill/>
@@ -7807,7 +7807,7 @@
             <a:r>
               <a:rPr sz="4000" b="0" i="0">
                 <a:solidFill>
-                  <a:srgbClr val="B0563A"/>
+                  <a:srgbClr val="D6749C"/>
                 </a:solidFill>
                 <a:latin typeface="Calibri"/>
               </a:rPr>
@@ -7926,7 +7926,7 @@
             </a:avLst>
           </a:prstGeom>
           <a:solidFill>
-            <a:srgbClr val="6B4A34"/>
+            <a:srgbClr val="6E8FC0"/>
           </a:solidFill>
           <a:ln>
             <a:noFill/>
@@ -8169,7 +8169,7 @@
             <a:r>
               <a:rPr sz="4000" b="0" i="0">
                 <a:solidFill>
-                  <a:srgbClr val="6B4A34"/>
+                  <a:srgbClr val="6E8FC0"/>
                 </a:solidFill>
                 <a:latin typeface="Calibri"/>
               </a:rPr>
@@ -9240,7 +9240,7 @@
             </a:avLst>
           </a:prstGeom>
           <a:solidFill>
-            <a:srgbClr val="6B4A34"/>
+            <a:srgbClr val="6E8FC0"/>
           </a:solidFill>
           <a:ln>
             <a:noFill/>
@@ -9483,7 +9483,7 @@
             <a:r>
               <a:rPr sz="4200" b="0" i="0">
                 <a:solidFill>
-                  <a:srgbClr val="6B4A34"/>
+                  <a:srgbClr val="6E8FC0"/>
                 </a:solidFill>
                 <a:latin typeface="Calibri"/>
               </a:rPr>
@@ -9522,7 +9522,7 @@
             <a:r>
               <a:rPr sz="1200" b="1" i="0" spc="160">
                 <a:solidFill>
-                  <a:srgbClr val="9B8571"/>
+                  <a:srgbClr val="6E8FC0"/>
                 </a:solidFill>
                 <a:latin typeface="Calibri"/>
               </a:rPr>
@@ -9548,7 +9548,7 @@
             </a:avLst>
           </a:prstGeom>
           <a:solidFill>
-            <a:srgbClr val="F1DED3"/>
+            <a:srgbClr val="F3DDE7"/>
           </a:solidFill>
           <a:ln>
             <a:noFill/>
@@ -9654,7 +9654,7 @@
             </a:avLst>
           </a:prstGeom>
           <a:solidFill>
-            <a:srgbClr val="B0563A"/>
+            <a:srgbClr val="D6749C"/>
           </a:solidFill>
           <a:ln>
             <a:noFill/>
@@ -9897,7 +9897,7 @@
             <a:r>
               <a:rPr sz="4200" b="0" i="0">
                 <a:solidFill>
-                  <a:srgbClr val="B0563A"/>
+                  <a:srgbClr val="D6749C"/>
                 </a:solidFill>
                 <a:latin typeface="Calibri"/>
               </a:rPr>
@@ -9936,7 +9936,7 @@
             <a:r>
               <a:rPr sz="2600" b="1" i="0">
                 <a:solidFill>
-                  <a:srgbClr val="B0563A"/>
+                  <a:srgbClr val="D6749C"/>
                 </a:solidFill>
                 <a:latin typeface="Calibri"/>
               </a:rPr>
@@ -9975,7 +9975,7 @@
             <a:r>
               <a:rPr sz="1200" b="1" i="0" spc="160">
                 <a:solidFill>
-                  <a:srgbClr val="B0563A"/>
+                  <a:srgbClr val="D6749C"/>
                 </a:solidFill>
                 <a:latin typeface="Calibri"/>
               </a:rPr>
@@ -10023,7 +10023,7 @@
             <a:r>
               <a:rPr sz="2500" b="1" i="0">
                 <a:solidFill>
-                  <a:srgbClr val="B0563A"/>
+                  <a:srgbClr val="D6749C"/>
                 </a:solidFill>
                 <a:latin typeface="Georgia"/>
               </a:rPr>
@@ -11463,7 +11463,7 @@
             <a:r>
               <a:rPr sz="4800" b="1" i="0">
                 <a:solidFill>
-                  <a:srgbClr val="6B4A34"/>
+                  <a:srgbClr val="6E8FC0"/>
                 </a:solidFill>
                 <a:latin typeface="Calibri"/>
               </a:rPr>
@@ -11590,7 +11590,7 @@
             <a:r>
               <a:rPr sz="4800" b="1" i="0">
                 <a:solidFill>
-                  <a:srgbClr val="B0563A"/>
+                  <a:srgbClr val="D6749C"/>
                 </a:solidFill>
                 <a:latin typeface="Calibri"/>
               </a:rPr>

</xml_diff>

<commit_message>
Bigger, brighter text; spell 'resume' without accents
- Global 1.16x font-size scale across all slides
- Brighter accent palette (rose, denim, terracotta, gold)
- Replaced all 'résumé' with plain 'resume'

Co-Authored-By: Claude Opus 4.8 <noreply@anthropic.com>
Claude-Session: https://claude.ai/code/session_01CjyAZ3oyttzTdGPrNqWN3p
</commit_message>
<xml_diff>
--- a/presentation/gender_bias_llm_hiring.pptx
+++ b/presentation/gender_bias_llm_hiring.pptx
@@ -3285,16 +3285,16 @@
               </a:lnSpc>
             </a:pPr>
             <a:r>
-              <a:rPr sz="6200" b="0" i="0">
+              <a:rPr sz="7192" b="0" i="0">
                 <a:solidFill>
-                  <a:srgbClr val="D6749C"/>
+                  <a:srgbClr val="E96CA4"/>
                 </a:solidFill>
                 <a:latin typeface="Calibri"/>
               </a:rPr>
               <a:t>♀</a:t>
             </a:r>
             <a:r>
-              <a:rPr sz="6200" b="0" i="0">
+              <a:rPr sz="7192" b="0" i="0">
                 <a:solidFill>
                   <a:srgbClr val="9B8571"/>
                 </a:solidFill>
@@ -3303,9 +3303,9 @@
               <a:t>   vs   </a:t>
             </a:r>
             <a:r>
-              <a:rPr sz="6200" b="0" i="0">
+              <a:rPr sz="7192" b="0" i="0">
                 <a:solidFill>
-                  <a:srgbClr val="6E8FC0"/>
+                  <a:srgbClr val="5A93DE"/>
                 </a:solidFill>
                 <a:latin typeface="Calibri"/>
               </a:rPr>
@@ -3322,8 +3322,8 @@
         </p:nvSpPr>
         <p:spPr>
           <a:xfrm>
-            <a:off x="883767" y="2880360"/>
-            <a:ext cx="10424160" cy="1737360"/>
+            <a:off x="518007" y="2880360"/>
+            <a:ext cx="11155680" cy="1737360"/>
           </a:xfrm>
           <a:prstGeom prst="rect">
             <a:avLst/>
@@ -3342,7 +3342,7 @@
               </a:lnSpc>
             </a:pPr>
             <a:r>
-              <a:rPr sz="4000" b="1" i="0">
+              <a:rPr sz="4291" b="1" i="0">
                 <a:solidFill>
                   <a:srgbClr val="3E2C1E"/>
                 </a:solidFill>
@@ -3351,22 +3351,22 @@
               <a:t>Gender bias when </a:t>
             </a:r>
             <a:r>
-              <a:rPr sz="4000" b="1" i="0">
+              <a:rPr sz="4291" b="1" i="0">
                 <a:solidFill>
-                  <a:srgbClr val="B0563A"/>
+                  <a:srgbClr val="CE5A38"/>
                 </a:solidFill>
                 <a:latin typeface="Georgia"/>
               </a:rPr>
               <a:t>AI</a:t>
             </a:r>
             <a:r>
-              <a:rPr sz="4000" b="1" i="0">
+              <a:rPr sz="4291" b="1" i="0">
                 <a:solidFill>
                   <a:srgbClr val="3E2C1E"/>
                 </a:solidFill>
                 <a:latin typeface="Georgia"/>
               </a:rPr>
-              <a:t> screens résumés</a:t>
+              <a:t> screens resumes</a:t>
             </a:r>
           </a:p>
         </p:txBody>
@@ -3399,9 +3399,9 @@
               </a:lnSpc>
             </a:pPr>
             <a:r>
-              <a:rPr sz="1500" b="1" i="0" spc="340">
+              <a:rPr sz="1739" b="1" i="0" spc="340">
                 <a:solidFill>
-                  <a:srgbClr val="A9744F"/>
+                  <a:srgbClr val="C18150"/>
                 </a:solidFill>
                 <a:latin typeface="Calibri"/>
               </a:rPr>
@@ -3508,16 +3508,16 @@
               </a:lnSpc>
             </a:pPr>
             <a:r>
-              <a:rPr sz="5800" b="0" i="0">
+              <a:rPr sz="6728" b="0" i="0">
                 <a:solidFill>
-                  <a:srgbClr val="D6749C"/>
+                  <a:srgbClr val="E96CA4"/>
                 </a:solidFill>
                 <a:latin typeface="Calibri"/>
               </a:rPr>
               <a:t>♀</a:t>
             </a:r>
             <a:r>
-              <a:rPr sz="5800" b="0" i="0">
+              <a:rPr sz="6728" b="0" i="0">
                 <a:solidFill>
                   <a:srgbClr val="3E2C1E"/>
                 </a:solidFill>
@@ -3526,9 +3526,9 @@
               <a:t>    </a:t>
             </a:r>
             <a:r>
-              <a:rPr sz="5800" b="0" i="0">
+              <a:rPr sz="6728" b="0" i="0">
                 <a:solidFill>
-                  <a:srgbClr val="6E8FC0"/>
+                  <a:srgbClr val="5A93DE"/>
                 </a:solidFill>
                 <a:latin typeface="Calibri"/>
               </a:rPr>
@@ -3565,7 +3565,7 @@
               </a:lnSpc>
             </a:pPr>
             <a:r>
-              <a:rPr sz="4800" b="1" i="0">
+              <a:rPr sz="5567" b="1" i="0">
                 <a:solidFill>
                   <a:srgbClr val="3E2C1E"/>
                 </a:solidFill>
@@ -3604,9 +3604,9 @@
               </a:lnSpc>
             </a:pPr>
             <a:r>
-              <a:rPr sz="1400" b="1" i="0" spc="160">
+              <a:rPr sz="1623" b="1" i="0" spc="160">
                 <a:solidFill>
-                  <a:srgbClr val="A9744F"/>
+                  <a:srgbClr val="C18150"/>
                 </a:solidFill>
                 <a:latin typeface="Calibri"/>
               </a:rPr>
@@ -3713,9 +3713,9 @@
               </a:lnSpc>
             </a:pPr>
             <a:r>
-              <a:rPr sz="1300" b="1" i="0" spc="420">
+              <a:rPr sz="1507" b="1" i="0" spc="420">
                 <a:solidFill>
-                  <a:srgbClr val="A9744F"/>
+                  <a:srgbClr val="C18150"/>
                 </a:solidFill>
                 <a:latin typeface="Calibri"/>
               </a:rPr>
@@ -3740,7 +3740,7 @@
           </a:prstGeom>
           <a:ln w="27940">
             <a:solidFill>
-              <a:srgbClr val="A9744F"/>
+              <a:srgbClr val="C18150"/>
             </a:solidFill>
           </a:ln>
           <a:effectLst/>
@@ -3973,7 +3973,7 @@
             <a:avLst/>
           </a:prstGeom>
           <a:solidFill>
-            <a:srgbClr val="A9744F"/>
+            <a:srgbClr val="C18150"/>
           </a:solidFill>
           <a:ln>
             <a:noFill/>
@@ -4297,7 +4297,7 @@
           </a:solidFill>
           <a:ln w="38100">
             <a:solidFill>
-              <a:srgbClr val="B0563A"/>
+              <a:srgbClr val="CE5A38"/>
             </a:solidFill>
           </a:ln>
           <a:effectLst>
@@ -4346,7 +4346,7 @@
           </a:prstGeom>
           <a:ln w="40640">
             <a:solidFill>
-              <a:srgbClr val="B0563A"/>
+              <a:srgbClr val="CE5A38"/>
             </a:solidFill>
           </a:ln>
           <a:effectLst/>
@@ -4538,9 +4538,9 @@
               </a:lnSpc>
             </a:pPr>
             <a:r>
-              <a:rPr sz="1200" b="1" i="0" spc="240">
+              <a:rPr sz="1507" b="1" i="0" spc="240">
                 <a:solidFill>
-                  <a:srgbClr val="9B8571"/>
+                  <a:srgbClr val="6B4A34"/>
                 </a:solidFill>
                 <a:latin typeface="Calibri"/>
               </a:rPr>
@@ -4577,9 +4577,9 @@
               </a:lnSpc>
             </a:pPr>
             <a:r>
-              <a:rPr sz="1200" b="1" i="0" spc="240">
+              <a:rPr sz="1507" b="1" i="0" spc="240">
                 <a:solidFill>
-                  <a:srgbClr val="A9744F"/>
+                  <a:srgbClr val="CE5A38"/>
                 </a:solidFill>
                 <a:latin typeface="Calibri"/>
               </a:rPr>
@@ -4616,9 +4616,9 @@
               </a:lnSpc>
             </a:pPr>
             <a:r>
-              <a:rPr sz="1200" b="1" i="0" spc="240">
+              <a:rPr sz="1507" b="1" i="0" spc="240">
                 <a:solidFill>
-                  <a:srgbClr val="9B8571"/>
+                  <a:srgbClr val="6B4A34"/>
                 </a:solidFill>
                 <a:latin typeface="Calibri"/>
               </a:rPr>
@@ -4655,13 +4655,13 @@
               </a:lnSpc>
             </a:pPr>
             <a:r>
-              <a:rPr sz="2500" b="1" i="0">
+              <a:rPr sz="2899" b="1" i="0">
                 <a:solidFill>
                   <a:srgbClr val="3E2C1E"/>
                 </a:solidFill>
                 <a:latin typeface="Georgia"/>
               </a:rPr>
-              <a:t>AI screens your résumé before a human ever sees it</a:t>
+              <a:t>AI screens your resume before a human ever sees it</a:t>
             </a:r>
           </a:p>
         </p:txBody>
@@ -4681,7 +4681,7 @@
             <a:avLst/>
           </a:prstGeom>
           <a:solidFill>
-            <a:srgbClr val="A9744F"/>
+            <a:srgbClr val="C18150"/>
           </a:solidFill>
           <a:ln>
             <a:noFill/>
@@ -4738,7 +4738,7 @@
               </a:lnSpc>
             </a:pPr>
             <a:r>
-              <a:rPr sz="1100" b="0" i="0">
+              <a:rPr sz="1276" b="0" i="0">
                 <a:solidFill>
                   <a:srgbClr val="9B8571"/>
                 </a:solidFill>
@@ -4847,9 +4847,9 @@
               </a:lnSpc>
             </a:pPr>
             <a:r>
-              <a:rPr sz="1300" b="1" i="0" spc="420">
+              <a:rPr sz="1507" b="1" i="0" spc="420">
                 <a:solidFill>
-                  <a:srgbClr val="A9744F"/>
+                  <a:srgbClr val="C18150"/>
                 </a:solidFill>
                 <a:latin typeface="Calibri"/>
               </a:rPr>
@@ -4874,7 +4874,7 @@
           </a:prstGeom>
           <a:ln w="27940">
             <a:solidFill>
-              <a:srgbClr val="A9744F"/>
+              <a:srgbClr val="C18150"/>
             </a:solidFill>
           </a:ln>
           <a:effectLst/>
@@ -4915,7 +4915,7 @@
           </a:solidFill>
           <a:ln w="15240">
             <a:solidFill>
-              <a:srgbClr val="A9744F"/>
+              <a:srgbClr val="C18150"/>
             </a:solidFill>
           </a:ln>
           <a:effectLst>
@@ -4965,7 +4965,7 @@
             </a:avLst>
           </a:prstGeom>
           <a:solidFill>
-            <a:srgbClr val="A9744F"/>
+            <a:srgbClr val="C18150"/>
           </a:solidFill>
           <a:ln>
             <a:noFill/>
@@ -5015,7 +5015,7 @@
           </a:solidFill>
           <a:ln w="15240">
             <a:solidFill>
-              <a:srgbClr val="B0563A"/>
+              <a:srgbClr val="CE5A38"/>
             </a:solidFill>
           </a:ln>
           <a:effectLst>
@@ -5065,7 +5065,7 @@
             </a:avLst>
           </a:prstGeom>
           <a:solidFill>
-            <a:srgbClr val="B0563A"/>
+            <a:srgbClr val="CE5A38"/>
           </a:solidFill>
           <a:ln>
             <a:noFill/>
@@ -5292,7 +5292,7 @@
             <a:avLst/>
           </a:prstGeom>
           <a:solidFill>
-            <a:srgbClr val="B0563A"/>
+            <a:srgbClr val="CE5A38"/>
           </a:solidFill>
           <a:ln>
             <a:noFill/>
@@ -5342,7 +5342,7 @@
           </a:solidFill>
           <a:ln w="27940">
             <a:solidFill>
-              <a:srgbClr val="A9744F"/>
+              <a:srgbClr val="C18150"/>
             </a:solidFill>
           </a:ln>
           <a:effectLst>
@@ -5390,7 +5390,7 @@
             <a:avLst/>
           </a:prstGeom>
           <a:solidFill>
-            <a:srgbClr val="A9744F"/>
+            <a:srgbClr val="C18150"/>
           </a:solidFill>
           <a:ln>
             <a:noFill/>
@@ -5434,7 +5434,7 @@
             <a:avLst/>
           </a:prstGeom>
           <a:solidFill>
-            <a:srgbClr val="A9744F"/>
+            <a:srgbClr val="C18150"/>
           </a:solidFill>
           <a:ln>
             <a:noFill/>
@@ -5480,7 +5480,7 @@
             </a:avLst>
           </a:prstGeom>
           <a:solidFill>
-            <a:srgbClr val="A9744F"/>
+            <a:srgbClr val="C18150"/>
           </a:solidFill>
           <a:ln>
             <a:noFill/>
@@ -5537,7 +5537,7 @@
               </a:lnSpc>
             </a:pPr>
             <a:r>
-              <a:rPr sz="1300" b="1" i="0" spc="140">
+              <a:rPr sz="1507" b="1" i="0" spc="140">
                 <a:solidFill>
                   <a:srgbClr val="5A4433"/>
                 </a:solidFill>
@@ -5576,7 +5576,7 @@
               </a:lnSpc>
             </a:pPr>
             <a:r>
-              <a:rPr sz="1300" b="1" i="0" spc="140">
+              <a:rPr sz="1507" b="1" i="0" spc="140">
                 <a:solidFill>
                   <a:srgbClr val="5A4433"/>
                 </a:solidFill>
@@ -5602,7 +5602,7 @@
             <a:avLst/>
           </a:prstGeom>
           <a:solidFill>
-            <a:srgbClr val="A9744F"/>
+            <a:srgbClr val="C18150"/>
           </a:solidFill>
           <a:ln>
             <a:noFill/>
@@ -5659,7 +5659,7 @@
               </a:lnSpc>
             </a:pPr>
             <a:r>
-              <a:rPr sz="1100" b="0" i="0">
+              <a:rPr sz="1276" b="0" i="0">
                 <a:solidFill>
                   <a:srgbClr val="9B8571"/>
                 </a:solidFill>
@@ -5768,9 +5768,9 @@
               </a:lnSpc>
             </a:pPr>
             <a:r>
-              <a:rPr sz="1300" b="1" i="0" spc="420">
+              <a:rPr sz="1507" b="1" i="0" spc="420">
                 <a:solidFill>
-                  <a:srgbClr val="B0563A"/>
+                  <a:srgbClr val="CE5A38"/>
                 </a:solidFill>
                 <a:latin typeface="Calibri"/>
               </a:rPr>
@@ -5795,7 +5795,7 @@
           </a:prstGeom>
           <a:ln w="27940">
             <a:solidFill>
-              <a:srgbClr val="B0563A"/>
+              <a:srgbClr val="CE5A38"/>
             </a:solidFill>
           </a:ln>
           <a:effectLst/>
@@ -5922,7 +5922,7 @@
             </a:avLst>
           </a:prstGeom>
           <a:solidFill>
-            <a:srgbClr val="A9744F"/>
+            <a:srgbClr val="C18150"/>
           </a:solidFill>
           <a:ln>
             <a:noFill/>
@@ -6073,9 +6073,9 @@
               </a:lnSpc>
             </a:pPr>
             <a:r>
-              <a:rPr sz="4800" b="1" i="0">
+              <a:rPr sz="5567" b="1" i="0">
                 <a:solidFill>
-                  <a:srgbClr val="6E8FC0"/>
+                  <a:srgbClr val="5A93DE"/>
                 </a:solidFill>
                 <a:latin typeface="Calibri"/>
               </a:rPr>
@@ -6200,9 +6200,9 @@
               </a:lnSpc>
             </a:pPr>
             <a:r>
-              <a:rPr sz="4800" b="1" i="0">
+              <a:rPr sz="5567" b="1" i="0">
                 <a:solidFill>
-                  <a:srgbClr val="D6749C"/>
+                  <a:srgbClr val="E96CA4"/>
                 </a:solidFill>
                 <a:latin typeface="Calibri"/>
               </a:rPr>
@@ -6239,9 +6239,9 @@
               </a:lnSpc>
             </a:pPr>
             <a:r>
-              <a:rPr sz="6600" b="1" i="0">
+              <a:rPr sz="7655" b="1" i="0">
                 <a:solidFill>
-                  <a:srgbClr val="B0563A"/>
+                  <a:srgbClr val="CE5A38"/>
                 </a:solidFill>
                 <a:latin typeface="Georgia"/>
               </a:rPr>
@@ -6278,7 +6278,7 @@
               </a:lnSpc>
             </a:pPr>
             <a:r>
-              <a:rPr sz="2400" b="1" i="0">
+              <a:rPr sz="2783" b="1" i="0">
                 <a:solidFill>
                   <a:srgbClr val="3E2C1E"/>
                 </a:solidFill>
@@ -6304,7 +6304,7 @@
             <a:avLst/>
           </a:prstGeom>
           <a:solidFill>
-            <a:srgbClr val="B0563A"/>
+            <a:srgbClr val="CE5A38"/>
           </a:solidFill>
           <a:ln>
             <a:noFill/>
@@ -6361,7 +6361,7 @@
               </a:lnSpc>
             </a:pPr>
             <a:r>
-              <a:rPr sz="1100" b="0" i="0">
+              <a:rPr sz="1276" b="0" i="0">
                 <a:solidFill>
                   <a:srgbClr val="9B8571"/>
                 </a:solidFill>
@@ -6470,9 +6470,9 @@
               </a:lnSpc>
             </a:pPr>
             <a:r>
-              <a:rPr sz="1300" b="1" i="0" spc="420">
+              <a:rPr sz="1507" b="1" i="0" spc="420">
                 <a:solidFill>
-                  <a:srgbClr val="A9744F"/>
+                  <a:srgbClr val="C18150"/>
                 </a:solidFill>
                 <a:latin typeface="Calibri"/>
               </a:rPr>
@@ -6497,7 +6497,7 @@
           </a:prstGeom>
           <a:ln w="27940">
             <a:solidFill>
-              <a:srgbClr val="A9744F"/>
+              <a:srgbClr val="C18150"/>
             </a:solidFill>
           </a:ln>
           <a:effectLst/>
@@ -6588,7 +6588,7 @@
             </a:avLst>
           </a:prstGeom>
           <a:solidFill>
-            <a:srgbClr val="D6749C"/>
+            <a:srgbClr val="E96CA4"/>
           </a:solidFill>
           <a:ln>
             <a:noFill/>
@@ -6725,7 +6725,7 @@
             </a:avLst>
           </a:prstGeom>
           <a:solidFill>
-            <a:srgbClr val="D6749C"/>
+            <a:srgbClr val="E96CA4"/>
           </a:solidFill>
           <a:ln>
             <a:noFill/>
@@ -6966,9 +6966,9 @@
               </a:lnSpc>
             </a:pPr>
             <a:r>
-              <a:rPr sz="3200" b="0" i="0">
+              <a:rPr sz="3711" b="0" i="0">
                 <a:solidFill>
-                  <a:srgbClr val="D6749C"/>
+                  <a:srgbClr val="E96CA4"/>
                 </a:solidFill>
                 <a:latin typeface="Calibri"/>
               </a:rPr>
@@ -7005,7 +7005,7 @@
               </a:lnSpc>
             </a:pPr>
             <a:r>
-              <a:rPr sz="4800" b="1" i="0">
+              <a:rPr sz="5567" b="1" i="0">
                 <a:solidFill>
                   <a:srgbClr val="9B8571"/>
                 </a:solidFill>
@@ -7087,7 +7087,7 @@
             </a:avLst>
           </a:prstGeom>
           <a:solidFill>
-            <a:srgbClr val="6E8FC0"/>
+            <a:srgbClr val="5A93DE"/>
           </a:solidFill>
           <a:ln>
             <a:noFill/>
@@ -7224,7 +7224,7 @@
             </a:avLst>
           </a:prstGeom>
           <a:solidFill>
-            <a:srgbClr val="6E8FC0"/>
+            <a:srgbClr val="5A93DE"/>
           </a:solidFill>
           <a:ln>
             <a:noFill/>
@@ -7465,9 +7465,9 @@
               </a:lnSpc>
             </a:pPr>
             <a:r>
-              <a:rPr sz="3200" b="0" i="0">
+              <a:rPr sz="3711" b="0" i="0">
                 <a:solidFill>
-                  <a:srgbClr val="6E8FC0"/>
+                  <a:srgbClr val="5A93DE"/>
                 </a:solidFill>
                 <a:latin typeface="Calibri"/>
               </a:rPr>
@@ -7504,13 +7504,13 @@
               </a:lnSpc>
             </a:pPr>
             <a:r>
-              <a:rPr sz="2400" b="1" i="0">
+              <a:rPr sz="2783" b="1" i="0">
                 <a:solidFill>
                   <a:srgbClr val="3E2C1E"/>
                 </a:solidFill>
                 <a:latin typeface="Georgia"/>
               </a:rPr>
-              <a:t>Identical Japanese résumés — only the name differs</a:t>
+              <a:t>Identical Japanese resumes — only the name differs</a:t>
             </a:r>
           </a:p>
         </p:txBody>
@@ -7543,13 +7543,13 @@
               </a:lnSpc>
             </a:pPr>
             <a:r>
-              <a:rPr sz="1150" b="1" i="0" spc="260">
+              <a:rPr sz="1334" b="1" i="0" spc="260">
                 <a:solidFill>
-                  <a:srgbClr val="A9744F"/>
+                  <a:srgbClr val="C18150"/>
                 </a:solidFill>
                 <a:latin typeface="Calibri"/>
               </a:rPr>
-              <a:t>FIVE AI MODELS SCORED EACH RÉSUMÉ</a:t>
+              <a:t>FIVE AI MODELS SCORED EACH RESUME</a:t>
             </a:r>
           </a:p>
         </p:txBody>
@@ -7623,7 +7623,7 @@
             <a:avLst/>
           </a:prstGeom>
           <a:solidFill>
-            <a:srgbClr val="B0563A"/>
+            <a:srgbClr val="CE5A38"/>
           </a:solidFill>
           <a:ln>
             <a:noFill/>
@@ -7680,7 +7680,7 @@
               </a:lnSpc>
             </a:pPr>
             <a:r>
-              <a:rPr sz="1500" b="1" i="0">
+              <a:rPr sz="1739" b="1" i="0">
                 <a:solidFill>
                   <a:srgbClr val="6B4A34"/>
                 </a:solidFill>
@@ -7760,7 +7760,7 @@
             <a:avLst/>
           </a:prstGeom>
           <a:solidFill>
-            <a:srgbClr val="A9744F"/>
+            <a:srgbClr val="C18150"/>
           </a:solidFill>
           <a:ln>
             <a:noFill/>
@@ -7817,7 +7817,7 @@
               </a:lnSpc>
             </a:pPr>
             <a:r>
-              <a:rPr sz="1500" b="1" i="0">
+              <a:rPr sz="1739" b="1" i="0">
                 <a:solidFill>
                   <a:srgbClr val="6B4A34"/>
                 </a:solidFill>
@@ -7897,7 +7897,7 @@
             <a:avLst/>
           </a:prstGeom>
           <a:solidFill>
-            <a:srgbClr val="B0563A"/>
+            <a:srgbClr val="CE5A38"/>
           </a:solidFill>
           <a:ln>
             <a:noFill/>
@@ -7954,7 +7954,7 @@
               </a:lnSpc>
             </a:pPr>
             <a:r>
-              <a:rPr sz="1500" b="1" i="0">
+              <a:rPr sz="1739" b="1" i="0">
                 <a:solidFill>
                   <a:srgbClr val="6B4A34"/>
                 </a:solidFill>
@@ -8034,7 +8034,7 @@
             <a:avLst/>
           </a:prstGeom>
           <a:solidFill>
-            <a:srgbClr val="A9744F"/>
+            <a:srgbClr val="C18150"/>
           </a:solidFill>
           <a:ln>
             <a:noFill/>
@@ -8091,7 +8091,7 @@
               </a:lnSpc>
             </a:pPr>
             <a:r>
-              <a:rPr sz="1500" b="1" i="0">
+              <a:rPr sz="1739" b="1" i="0">
                 <a:solidFill>
                   <a:srgbClr val="6B4A34"/>
                 </a:solidFill>
@@ -8171,7 +8171,7 @@
             <a:avLst/>
           </a:prstGeom>
           <a:solidFill>
-            <a:srgbClr val="B0563A"/>
+            <a:srgbClr val="CE5A38"/>
           </a:solidFill>
           <a:ln>
             <a:noFill/>
@@ -8228,7 +8228,7 @@
               </a:lnSpc>
             </a:pPr>
             <a:r>
-              <a:rPr sz="1500" b="1" i="0">
+              <a:rPr sz="1739" b="1" i="0">
                 <a:solidFill>
                   <a:srgbClr val="6B4A34"/>
                 </a:solidFill>
@@ -8254,7 +8254,7 @@
             <a:avLst/>
           </a:prstGeom>
           <a:solidFill>
-            <a:srgbClr val="A9744F"/>
+            <a:srgbClr val="C18150"/>
           </a:solidFill>
           <a:ln>
             <a:noFill/>
@@ -8311,7 +8311,7 @@
               </a:lnSpc>
             </a:pPr>
             <a:r>
-              <a:rPr sz="1100" b="0" i="0">
+              <a:rPr sz="1276" b="0" i="0">
                 <a:solidFill>
                   <a:srgbClr val="9B8571"/>
                 </a:solidFill>
@@ -8420,9 +8420,9 @@
               </a:lnSpc>
             </a:pPr>
             <a:r>
-              <a:rPr sz="1300" b="1" i="0" spc="420">
+              <a:rPr sz="1507" b="1" i="0" spc="420">
                 <a:solidFill>
-                  <a:srgbClr val="B0563A"/>
+                  <a:srgbClr val="CE5A38"/>
                 </a:solidFill>
                 <a:latin typeface="Calibri"/>
               </a:rPr>
@@ -8447,7 +8447,7 @@
           </a:prstGeom>
           <a:ln w="27940">
             <a:solidFill>
-              <a:srgbClr val="B0563A"/>
+              <a:srgbClr val="CE5A38"/>
             </a:solidFill>
           </a:ln>
           <a:effectLst/>
@@ -8538,7 +8538,7 @@
             </a:avLst>
           </a:prstGeom>
           <a:solidFill>
-            <a:srgbClr val="6E8FC0"/>
+            <a:srgbClr val="5A93DE"/>
           </a:solidFill>
           <a:ln>
             <a:noFill/>
@@ -8675,7 +8675,7 @@
             </a:avLst>
           </a:prstGeom>
           <a:solidFill>
-            <a:srgbClr val="6E8FC0"/>
+            <a:srgbClr val="5A93DE"/>
           </a:solidFill>
           <a:ln>
             <a:noFill/>
@@ -8916,9 +8916,9 @@
               </a:lnSpc>
             </a:pPr>
             <a:r>
-              <a:rPr sz="3400" b="0" i="0">
+              <a:rPr sz="3944" b="0" i="0">
                 <a:solidFill>
-                  <a:srgbClr val="6E8FC0"/>
+                  <a:srgbClr val="5A93DE"/>
                 </a:solidFill>
                 <a:latin typeface="Calibri"/>
               </a:rPr>
@@ -8955,9 +8955,9 @@
               </a:lnSpc>
             </a:pPr>
             <a:r>
-              <a:rPr sz="1200" b="1" i="0" spc="160">
+              <a:rPr sz="1391" b="1" i="0" spc="160">
                 <a:solidFill>
-                  <a:srgbClr val="6E8FC0"/>
+                  <a:srgbClr val="5A93DE"/>
                 </a:solidFill>
                 <a:latin typeface="Calibri"/>
               </a:rPr>
@@ -9089,7 +9089,7 @@
             </a:avLst>
           </a:prstGeom>
           <a:solidFill>
-            <a:srgbClr val="D6749C"/>
+            <a:srgbClr val="E96CA4"/>
           </a:solidFill>
           <a:ln>
             <a:noFill/>
@@ -9226,7 +9226,7 @@
             </a:avLst>
           </a:prstGeom>
           <a:solidFill>
-            <a:srgbClr val="D6749C"/>
+            <a:srgbClr val="E96CA4"/>
           </a:solidFill>
           <a:ln>
             <a:noFill/>
@@ -9467,9 +9467,9 @@
               </a:lnSpc>
             </a:pPr>
             <a:r>
-              <a:rPr sz="3400" b="0" i="0">
+              <a:rPr sz="3944" b="0" i="0">
                 <a:solidFill>
-                  <a:srgbClr val="D6749C"/>
+                  <a:srgbClr val="E96CA4"/>
                 </a:solidFill>
                 <a:latin typeface="Calibri"/>
               </a:rPr>
@@ -9506,9 +9506,9 @@
               </a:lnSpc>
             </a:pPr>
             <a:r>
-              <a:rPr sz="2600" b="1" i="0">
+              <a:rPr sz="3015" b="1" i="0">
                 <a:solidFill>
-                  <a:srgbClr val="D6749C"/>
+                  <a:srgbClr val="E96CA4"/>
                 </a:solidFill>
                 <a:latin typeface="Calibri"/>
               </a:rPr>
@@ -9545,9 +9545,9 @@
               </a:lnSpc>
             </a:pPr>
             <a:r>
-              <a:rPr sz="1200" b="1" i="0" spc="160">
+              <a:rPr sz="1391" b="1" i="0" spc="160">
                 <a:solidFill>
-                  <a:srgbClr val="D6749C"/>
+                  <a:srgbClr val="E96CA4"/>
                 </a:solidFill>
                 <a:latin typeface="Calibri"/>
               </a:rPr>
@@ -9584,7 +9584,7 @@
               </a:lnSpc>
             </a:pPr>
             <a:r>
-              <a:rPr sz="2500" b="1" i="0">
+              <a:rPr sz="2899" b="1" i="0">
                 <a:solidFill>
                   <a:srgbClr val="3E2C1E"/>
                 </a:solidFill>
@@ -9593,22 +9593,22 @@
               <a:t>Female names scored </a:t>
             </a:r>
             <a:r>
-              <a:rPr sz="2500" b="1" i="0">
+              <a:rPr sz="2899" b="1" i="0">
                 <a:solidFill>
-                  <a:srgbClr val="D6749C"/>
+                  <a:srgbClr val="E96CA4"/>
                 </a:solidFill>
                 <a:latin typeface="Georgia"/>
               </a:rPr>
               <a:t>slightly higher</a:t>
             </a:r>
             <a:r>
-              <a:rPr sz="2500" b="1" i="0">
+              <a:rPr sz="2899" b="1" i="0">
                 <a:solidFill>
                   <a:srgbClr val="3E2C1E"/>
                 </a:solidFill>
                 <a:latin typeface="Georgia"/>
               </a:rPr>
-              <a:t> — same résumé</a:t>
+              <a:t> — same resume</a:t>
             </a:r>
           </a:p>
         </p:txBody>
@@ -9628,7 +9628,7 @@
             <a:avLst/>
           </a:prstGeom>
           <a:solidFill>
-            <a:srgbClr val="B0563A"/>
+            <a:srgbClr val="CE5A38"/>
           </a:solidFill>
           <a:ln>
             <a:noFill/>
@@ -9685,7 +9685,7 @@
               </a:lnSpc>
             </a:pPr>
             <a:r>
-              <a:rPr sz="1100" b="0" i="0">
+              <a:rPr sz="1276" b="0" i="0">
                 <a:solidFill>
                   <a:srgbClr val="9B8571"/>
                 </a:solidFill>
@@ -9794,9 +9794,9 @@
               </a:lnSpc>
             </a:pPr>
             <a:r>
-              <a:rPr sz="1300" b="1" i="0" spc="420">
+              <a:rPr sz="1507" b="1" i="0" spc="420">
                 <a:solidFill>
-                  <a:srgbClr val="BE932E"/>
+                  <a:srgbClr val="DCA62A"/>
                 </a:solidFill>
                 <a:latin typeface="Calibri"/>
               </a:rPr>
@@ -9821,7 +9821,7 @@
           </a:prstGeom>
           <a:ln w="27940">
             <a:solidFill>
-              <a:srgbClr val="BE932E"/>
+              <a:srgbClr val="DCA62A"/>
             </a:solidFill>
           </a:ln>
           <a:effectLst/>
@@ -9912,7 +9912,7 @@
             </a:avLst>
           </a:prstGeom>
           <a:solidFill>
-            <a:srgbClr val="A9744F"/>
+            <a:srgbClr val="C18150"/>
           </a:solidFill>
           <a:ln>
             <a:noFill/>
@@ -10049,7 +10049,7 @@
             </a:avLst>
           </a:prstGeom>
           <a:solidFill>
-            <a:srgbClr val="A9744F"/>
+            <a:srgbClr val="C18150"/>
           </a:solidFill>
           <a:ln>
             <a:noFill/>
@@ -10667,7 +10667,7 @@
               </a:lnSpc>
             </a:pPr>
             <a:r>
-              <a:rPr sz="1250" b="1" i="0">
+              <a:rPr sz="1449" b="1" i="0">
                 <a:solidFill>
                   <a:srgbClr val="6B4A34"/>
                 </a:solidFill>
@@ -10706,9 +10706,9 @@
               </a:lnSpc>
             </a:pPr>
             <a:r>
-              <a:rPr sz="5800" b="1" i="0">
+              <a:rPr sz="6728" b="1" i="0">
                 <a:solidFill>
-                  <a:srgbClr val="BE932E"/>
+                  <a:srgbClr val="DCA62A"/>
                 </a:solidFill>
                 <a:latin typeface="Calibri"/>
               </a:rPr>
@@ -10745,7 +10745,7 @@
               </a:lnSpc>
             </a:pPr>
             <a:r>
-              <a:rPr sz="2500" b="1" i="0">
+              <a:rPr sz="2899" b="1" i="0">
                 <a:solidFill>
                   <a:srgbClr val="3E2C1E"/>
                 </a:solidFill>
@@ -10771,7 +10771,7 @@
             <a:avLst/>
           </a:prstGeom>
           <a:solidFill>
-            <a:srgbClr val="BE932E"/>
+            <a:srgbClr val="DCA62A"/>
           </a:solidFill>
           <a:ln>
             <a:noFill/>
@@ -10828,7 +10828,7 @@
               </a:lnSpc>
             </a:pPr>
             <a:r>
-              <a:rPr sz="1100" b="0" i="0">
+              <a:rPr sz="1276" b="0" i="0">
                 <a:solidFill>
                   <a:srgbClr val="9B8571"/>
                 </a:solidFill>
@@ -10937,9 +10937,9 @@
               </a:lnSpc>
             </a:pPr>
             <a:r>
-              <a:rPr sz="1300" b="1" i="0" spc="420">
+              <a:rPr sz="1507" b="1" i="0" spc="420">
                 <a:solidFill>
-                  <a:srgbClr val="A9744F"/>
+                  <a:srgbClr val="C18150"/>
                 </a:solidFill>
                 <a:latin typeface="Calibri"/>
               </a:rPr>
@@ -10964,7 +10964,7 @@
           </a:prstGeom>
           <a:ln w="27940">
             <a:solidFill>
-              <a:srgbClr val="A9744F"/>
+              <a:srgbClr val="C18150"/>
             </a:solidFill>
           </a:ln>
           <a:effectLst/>
@@ -11091,7 +11091,7 @@
             </a:avLst>
           </a:prstGeom>
           <a:solidFill>
-            <a:srgbClr val="A9744F"/>
+            <a:srgbClr val="C18150"/>
           </a:solidFill>
           <a:ln>
             <a:noFill/>
@@ -11242,9 +11242,9 @@
               </a:lnSpc>
             </a:pPr>
             <a:r>
-              <a:rPr sz="4800" b="1" i="0">
+              <a:rPr sz="5567" b="1" i="0">
                 <a:solidFill>
-                  <a:srgbClr val="6E8FC0"/>
+                  <a:srgbClr val="5A93DE"/>
                 </a:solidFill>
                 <a:latin typeface="Calibri"/>
               </a:rPr>
@@ -11369,9 +11369,9 @@
               </a:lnSpc>
             </a:pPr>
             <a:r>
-              <a:rPr sz="4800" b="1" i="0">
+              <a:rPr sz="5567" b="1" i="0">
                 <a:solidFill>
-                  <a:srgbClr val="D6749C"/>
+                  <a:srgbClr val="E96CA4"/>
                 </a:solidFill>
                 <a:latin typeface="Calibri"/>
               </a:rPr>
@@ -11388,8 +11388,8 @@
         </p:nvSpPr>
         <p:spPr>
           <a:xfrm>
-            <a:off x="700887" y="5486400"/>
-            <a:ext cx="10789920" cy="868680"/>
+            <a:off x="518007" y="5486400"/>
+            <a:ext cx="11155680" cy="868680"/>
           </a:xfrm>
           <a:prstGeom prst="rect">
             <a:avLst/>
@@ -11408,13 +11408,13 @@
               </a:lnSpc>
             </a:pPr>
             <a:r>
-              <a:rPr sz="2300" b="1" i="0">
+              <a:rPr sz="2668" b="1" i="0">
                 <a:solidFill>
                   <a:srgbClr val="3E2C1E"/>
                 </a:solidFill>
                 <a:latin typeface="Georgia"/>
               </a:rPr>
-              <a:t>Fairness training may over-correct — tipping slightly toward women</a:t>
+              <a:t>Fairness training may over-correct — tipping toward women</a:t>
             </a:r>
           </a:p>
         </p:txBody>
@@ -11434,7 +11434,7 @@
             <a:avLst/>
           </a:prstGeom>
           <a:solidFill>
-            <a:srgbClr val="A9744F"/>
+            <a:srgbClr val="C18150"/>
           </a:solidFill>
           <a:ln>
             <a:noFill/>
@@ -11491,7 +11491,7 @@
               </a:lnSpc>
             </a:pPr>
             <a:r>
-              <a:rPr sz="1100" b="0" i="0">
+              <a:rPr sz="1276" b="0" i="0">
                 <a:solidFill>
                   <a:srgbClr val="9B8571"/>
                 </a:solidFill>
@@ -11600,9 +11600,9 @@
               </a:lnSpc>
             </a:pPr>
             <a:r>
-              <a:rPr sz="1300" b="1" i="0" spc="420">
+              <a:rPr sz="1507" b="1" i="0" spc="420">
                 <a:solidFill>
-                  <a:srgbClr val="A9744F"/>
+                  <a:srgbClr val="C18150"/>
                 </a:solidFill>
                 <a:latin typeface="Calibri"/>
               </a:rPr>
@@ -11627,7 +11627,7 @@
           </a:prstGeom>
           <a:ln w="27940">
             <a:solidFill>
-              <a:srgbClr val="A9744F"/>
+              <a:srgbClr val="C18150"/>
             </a:solidFill>
           </a:ln>
           <a:effectLst/>
@@ -11675,7 +11675,7 @@
               </a:lnSpc>
             </a:pPr>
             <a:r>
-              <a:rPr sz="3300" b="1" i="0">
+              <a:rPr sz="3827" b="1" i="0">
                 <a:solidFill>
                   <a:srgbClr val="3E2C1E"/>
                 </a:solidFill>
@@ -11691,7 +11691,7 @@
               </a:lnSpc>
             </a:pPr>
             <a:r>
-              <a:rPr sz="3300" b="1" i="0">
+              <a:rPr sz="3827" b="1" i="0">
                 <a:solidFill>
                   <a:srgbClr val="3E2C1E"/>
                 </a:solidFill>
@@ -11700,9 +11700,9 @@
               <a:t/>
             </a:r>
             <a:r>
-              <a:rPr sz="3300" b="1" i="0">
+              <a:rPr sz="3827" b="1" i="0">
                 <a:solidFill>
-                  <a:srgbClr val="B0563A"/>
+                  <a:srgbClr val="CE5A38"/>
                 </a:solidFill>
                 <a:latin typeface="Georgia"/>
               </a:rPr>
@@ -11739,9 +11739,9 @@
               </a:lnSpc>
             </a:pPr>
             <a:r>
-              <a:rPr sz="2000" b="1" i="1">
+              <a:rPr sz="2320" b="1" i="1">
                 <a:solidFill>
-                  <a:srgbClr val="A9744F"/>
+                  <a:srgbClr val="C18150"/>
                 </a:solidFill>
                 <a:latin typeface="Georgia"/>
               </a:rPr>
@@ -11765,7 +11765,7 @@
             <a:avLst/>
           </a:prstGeom>
           <a:solidFill>
-            <a:srgbClr val="A9744F"/>
+            <a:srgbClr val="C18150"/>
           </a:solidFill>
           <a:ln>
             <a:noFill/>
@@ -11822,7 +11822,7 @@
               </a:lnSpc>
             </a:pPr>
             <a:r>
-              <a:rPr sz="1100" b="0" i="0">
+              <a:rPr sz="1276" b="0" i="0">
                 <a:solidFill>
                   <a:srgbClr val="9B8571"/>
                 </a:solidFill>

</xml_diff>

<commit_message>
Bigger headings, study name on title, cartoon resumes, two-color people
- Enlarged all slide headings and eyebrow labels
- Title slide now cites the full study name and flanks it with two cartoon
  resumes (pink female / blue male) — filling the former blank cards
- YOU (caramel) and RECRUITER (walnut) drawn in two different colors

Co-Authored-By: Claude Opus 4.8 <noreply@anthropic.com>
Claude-Session: https://claude.ai/code/session_01CjyAZ3oyttzTdGPrNqWN3p
</commit_message>
<xml_diff>
--- a/presentation/gender_bias_llm_hiring.pptx
+++ b/presentation/gender_bias_llm_hiring.pptx
@@ -3156,9 +3156,9 @@
           <p:nvPr/>
         </p:nvSpPr>
         <p:spPr>
-          <a:xfrm rot="21060000">
-            <a:off x="868680" y="1143000"/>
-            <a:ext cx="1691640" cy="2148840"/>
+          <a:xfrm>
+            <a:off x="960119" y="1965960"/>
+            <a:ext cx="1828800" cy="2377440"/>
           </a:xfrm>
           <a:prstGeom prst="roundRect">
             <a:avLst>
@@ -3168,7 +3168,7 @@
           <a:solidFill>
             <a:srgbClr val="FCF7EF"/>
           </a:solidFill>
-          <a:ln w="12700">
+          <a:ln w="16510">
             <a:solidFill>
               <a:srgbClr val="E4D5C0"/>
             </a:solidFill>
@@ -3210,9 +3210,415 @@
           <p:nvPr/>
         </p:nvSpPr>
         <p:spPr>
-          <a:xfrm rot="480000">
-            <a:off x="9646920" y="3611880"/>
-            <a:ext cx="1691640" cy="2148840"/>
+          <a:xfrm>
+            <a:off x="1929384" y="2240280"/>
+            <a:ext cx="585216" cy="655441"/>
+          </a:xfrm>
+          <a:prstGeom prst="roundRect">
+            <a:avLst>
+              <a:gd name="adj" fmla="val 12000"/>
+            </a:avLst>
+          </a:prstGeom>
+          <a:solidFill>
+            <a:srgbClr val="E96CA4"/>
+          </a:solidFill>
+          <a:ln>
+            <a:noFill/>
+          </a:ln>
+          <a:effectLst/>
+        </p:spPr>
+        <p:style>
+          <a:lnRef idx="1">
+            <a:schemeClr val="accent1"/>
+          </a:lnRef>
+          <a:fillRef idx="3">
+            <a:schemeClr val="accent1"/>
+          </a:fillRef>
+          <a:effectRef idx="2">
+            <a:schemeClr val="accent1"/>
+          </a:effectRef>
+          <a:fontRef idx="minor">
+            <a:schemeClr val="lt1"/>
+          </a:fontRef>
+        </p:style>
+        <p:txBody>
+          <a:bodyPr rtlCol="0" anchor="ctr"/>
+          <a:lstStyle/>
+          <a:p>
+            <a:pPr algn="ctr"/>
+          </a:p>
+        </p:txBody>
+      </p:sp>
+      <p:sp>
+        <p:nvSpPr>
+          <p:cNvPr id="5" name="Oval 4"/>
+          <p:cNvSpPr/>
+          <p:nvPr/>
+        </p:nvSpPr>
+        <p:spPr>
+          <a:xfrm>
+            <a:off x="2104948" y="2322210"/>
+            <a:ext cx="234086" cy="234086"/>
+          </a:xfrm>
+          <a:prstGeom prst="ellipse">
+            <a:avLst/>
+          </a:prstGeom>
+          <a:solidFill>
+            <a:srgbClr val="FCF7EF"/>
+          </a:solidFill>
+          <a:ln>
+            <a:noFill/>
+          </a:ln>
+          <a:effectLst/>
+        </p:spPr>
+        <p:style>
+          <a:lnRef idx="1">
+            <a:schemeClr val="accent1"/>
+          </a:lnRef>
+          <a:fillRef idx="3">
+            <a:schemeClr val="accent1"/>
+          </a:fillRef>
+          <a:effectRef idx="2">
+            <a:schemeClr val="accent1"/>
+          </a:effectRef>
+          <a:fontRef idx="minor">
+            <a:schemeClr val="lt1"/>
+          </a:fontRef>
+        </p:style>
+        <p:txBody>
+          <a:bodyPr rtlCol="0" anchor="ctr"/>
+          <a:lstStyle/>
+          <a:p>
+            <a:pPr algn="ctr"/>
+          </a:p>
+        </p:txBody>
+      </p:sp>
+      <p:sp>
+        <p:nvSpPr>
+          <p:cNvPr id="6" name="Round Same Side Corner Rectangle 5"/>
+          <p:cNvSpPr/>
+          <p:nvPr/>
+        </p:nvSpPr>
+        <p:spPr>
+          <a:xfrm>
+            <a:off x="2023018" y="2579705"/>
+            <a:ext cx="397946" cy="198973"/>
+          </a:xfrm>
+          <a:prstGeom prst="round2SameRect">
+            <a:avLst>
+              <a:gd name="adj1" fmla="val 50000"/>
+              <a:gd name="adj2" fmla="val 0"/>
+            </a:avLst>
+          </a:prstGeom>
+          <a:solidFill>
+            <a:srgbClr val="FCF7EF"/>
+          </a:solidFill>
+          <a:ln>
+            <a:noFill/>
+          </a:ln>
+          <a:effectLst/>
+        </p:spPr>
+        <p:style>
+          <a:lnRef idx="1">
+            <a:schemeClr val="accent1"/>
+          </a:lnRef>
+          <a:fillRef idx="3">
+            <a:schemeClr val="accent1"/>
+          </a:fillRef>
+          <a:effectRef idx="2">
+            <a:schemeClr val="accent1"/>
+          </a:effectRef>
+          <a:fontRef idx="minor">
+            <a:schemeClr val="lt1"/>
+          </a:fontRef>
+        </p:style>
+        <p:txBody>
+          <a:bodyPr rtlCol="0" anchor="ctr"/>
+          <a:lstStyle/>
+          <a:p>
+            <a:pPr algn="ctr"/>
+          </a:p>
+        </p:txBody>
+      </p:sp>
+      <p:sp>
+        <p:nvSpPr>
+          <p:cNvPr id="7" name="Rounded Rectangle 6"/>
+          <p:cNvSpPr/>
+          <p:nvPr/>
+        </p:nvSpPr>
+        <p:spPr>
+          <a:xfrm>
+            <a:off x="1234439" y="2267712"/>
+            <a:ext cx="731520" cy="142646"/>
+          </a:xfrm>
+          <a:prstGeom prst="roundRect">
+            <a:avLst>
+              <a:gd name="adj" fmla="val 50000"/>
+            </a:avLst>
+          </a:prstGeom>
+          <a:solidFill>
+            <a:srgbClr val="E96CA4"/>
+          </a:solidFill>
+          <a:ln>
+            <a:noFill/>
+          </a:ln>
+          <a:effectLst/>
+        </p:spPr>
+        <p:style>
+          <a:lnRef idx="1">
+            <a:schemeClr val="accent1"/>
+          </a:lnRef>
+          <a:fillRef idx="3">
+            <a:schemeClr val="accent1"/>
+          </a:fillRef>
+          <a:effectRef idx="2">
+            <a:schemeClr val="accent1"/>
+          </a:effectRef>
+          <a:fontRef idx="minor">
+            <a:schemeClr val="lt1"/>
+          </a:fontRef>
+        </p:style>
+        <p:txBody>
+          <a:bodyPr rtlCol="0" anchor="ctr"/>
+          <a:lstStyle/>
+          <a:p>
+            <a:pPr algn="ctr"/>
+          </a:p>
+        </p:txBody>
+      </p:sp>
+      <p:sp>
+        <p:nvSpPr>
+          <p:cNvPr id="8" name="Rounded Rectangle 7"/>
+          <p:cNvSpPr/>
+          <p:nvPr/>
+        </p:nvSpPr>
+        <p:spPr>
+          <a:xfrm>
+            <a:off x="1234439" y="2596896"/>
+            <a:ext cx="585216" cy="106984"/>
+          </a:xfrm>
+          <a:prstGeom prst="roundRect">
+            <a:avLst>
+              <a:gd name="adj" fmla="val 50000"/>
+            </a:avLst>
+          </a:prstGeom>
+          <a:solidFill>
+            <a:srgbClr val="E4D5C0"/>
+          </a:solidFill>
+          <a:ln>
+            <a:noFill/>
+          </a:ln>
+          <a:effectLst/>
+        </p:spPr>
+        <p:style>
+          <a:lnRef idx="1">
+            <a:schemeClr val="accent1"/>
+          </a:lnRef>
+          <a:fillRef idx="3">
+            <a:schemeClr val="accent1"/>
+          </a:fillRef>
+          <a:effectRef idx="2">
+            <a:schemeClr val="accent1"/>
+          </a:effectRef>
+          <a:fontRef idx="minor">
+            <a:schemeClr val="lt1"/>
+          </a:fontRef>
+        </p:style>
+        <p:txBody>
+          <a:bodyPr rtlCol="0" anchor="ctr"/>
+          <a:lstStyle/>
+          <a:p>
+            <a:pPr algn="ctr"/>
+          </a:p>
+        </p:txBody>
+      </p:sp>
+      <p:sp>
+        <p:nvSpPr>
+          <p:cNvPr id="9" name="Rounded Rectangle 8"/>
+          <p:cNvSpPr/>
+          <p:nvPr/>
+        </p:nvSpPr>
+        <p:spPr>
+          <a:xfrm>
+            <a:off x="1234439" y="3035808"/>
+            <a:ext cx="1316736" cy="106984"/>
+          </a:xfrm>
+          <a:prstGeom prst="roundRect">
+            <a:avLst>
+              <a:gd name="adj" fmla="val 50000"/>
+            </a:avLst>
+          </a:prstGeom>
+          <a:solidFill>
+            <a:srgbClr val="E4D5C0"/>
+          </a:solidFill>
+          <a:ln>
+            <a:noFill/>
+          </a:ln>
+          <a:effectLst/>
+        </p:spPr>
+        <p:style>
+          <a:lnRef idx="1">
+            <a:schemeClr val="accent1"/>
+          </a:lnRef>
+          <a:fillRef idx="3">
+            <a:schemeClr val="accent1"/>
+          </a:fillRef>
+          <a:effectRef idx="2">
+            <a:schemeClr val="accent1"/>
+          </a:effectRef>
+          <a:fontRef idx="minor">
+            <a:schemeClr val="lt1"/>
+          </a:fontRef>
+        </p:style>
+        <p:txBody>
+          <a:bodyPr rtlCol="0" anchor="ctr"/>
+          <a:lstStyle/>
+          <a:p>
+            <a:pPr algn="ctr"/>
+          </a:p>
+        </p:txBody>
+      </p:sp>
+      <p:sp>
+        <p:nvSpPr>
+          <p:cNvPr id="10" name="Rounded Rectangle 9"/>
+          <p:cNvSpPr/>
+          <p:nvPr/>
+        </p:nvSpPr>
+        <p:spPr>
+          <a:xfrm>
+            <a:off x="1234439" y="3321100"/>
+            <a:ext cx="1170432" cy="106984"/>
+          </a:xfrm>
+          <a:prstGeom prst="roundRect">
+            <a:avLst>
+              <a:gd name="adj" fmla="val 50000"/>
+            </a:avLst>
+          </a:prstGeom>
+          <a:solidFill>
+            <a:srgbClr val="E4D5C0"/>
+          </a:solidFill>
+          <a:ln>
+            <a:noFill/>
+          </a:ln>
+          <a:effectLst/>
+        </p:spPr>
+        <p:style>
+          <a:lnRef idx="1">
+            <a:schemeClr val="accent1"/>
+          </a:lnRef>
+          <a:fillRef idx="3">
+            <a:schemeClr val="accent1"/>
+          </a:fillRef>
+          <a:effectRef idx="2">
+            <a:schemeClr val="accent1"/>
+          </a:effectRef>
+          <a:fontRef idx="minor">
+            <a:schemeClr val="lt1"/>
+          </a:fontRef>
+        </p:style>
+        <p:txBody>
+          <a:bodyPr rtlCol="0" anchor="ctr"/>
+          <a:lstStyle/>
+          <a:p>
+            <a:pPr algn="ctr"/>
+          </a:p>
+        </p:txBody>
+      </p:sp>
+      <p:sp>
+        <p:nvSpPr>
+          <p:cNvPr id="11" name="Rounded Rectangle 10"/>
+          <p:cNvSpPr/>
+          <p:nvPr/>
+        </p:nvSpPr>
+        <p:spPr>
+          <a:xfrm>
+            <a:off x="1234439" y="3606393"/>
+            <a:ext cx="1243584" cy="106984"/>
+          </a:xfrm>
+          <a:prstGeom prst="roundRect">
+            <a:avLst>
+              <a:gd name="adj" fmla="val 50000"/>
+            </a:avLst>
+          </a:prstGeom>
+          <a:solidFill>
+            <a:srgbClr val="E4D5C0"/>
+          </a:solidFill>
+          <a:ln>
+            <a:noFill/>
+          </a:ln>
+          <a:effectLst/>
+        </p:spPr>
+        <p:style>
+          <a:lnRef idx="1">
+            <a:schemeClr val="accent1"/>
+          </a:lnRef>
+          <a:fillRef idx="3">
+            <a:schemeClr val="accent1"/>
+          </a:fillRef>
+          <a:effectRef idx="2">
+            <a:schemeClr val="accent1"/>
+          </a:effectRef>
+          <a:fontRef idx="minor">
+            <a:schemeClr val="lt1"/>
+          </a:fontRef>
+        </p:style>
+        <p:txBody>
+          <a:bodyPr rtlCol="0" anchor="ctr"/>
+          <a:lstStyle/>
+          <a:p>
+            <a:pPr algn="ctr"/>
+          </a:p>
+        </p:txBody>
+      </p:sp>
+      <p:sp>
+        <p:nvSpPr>
+          <p:cNvPr id="12" name="TextBox 11"/>
+          <p:cNvSpPr txBox="1"/>
+          <p:nvPr/>
+        </p:nvSpPr>
+        <p:spPr>
+          <a:xfrm>
+            <a:off x="960119" y="3772814"/>
+            <a:ext cx="1828800" cy="618134"/>
+          </a:xfrm>
+          <a:prstGeom prst="rect">
+            <a:avLst/>
+          </a:prstGeom>
+          <a:noFill/>
+        </p:spPr>
+        <p:txBody>
+          <a:bodyPr wrap="square" anchor="ctr" lIns="0" rIns="0" tIns="0" bIns="0">
+            <a:spAutoFit/>
+          </a:bodyPr>
+          <a:lstStyle/>
+          <a:p>
+            <a:pPr algn="ctr">
+              <a:lnSpc>
+                <a:spcPct val="100000"/>
+              </a:lnSpc>
+            </a:pPr>
+            <a:r>
+              <a:rPr sz="4176" b="0" i="0">
+                <a:solidFill>
+                  <a:srgbClr val="E96CA4"/>
+                </a:solidFill>
+                <a:latin typeface="Calibri"/>
+              </a:rPr>
+              <a:t>♀</a:t>
+            </a:r>
+          </a:p>
+        </p:txBody>
+      </p:sp>
+      <p:sp>
+        <p:nvSpPr>
+          <p:cNvPr id="13" name="Rounded Rectangle 12"/>
+          <p:cNvSpPr/>
+          <p:nvPr/>
+        </p:nvSpPr>
+        <p:spPr>
+          <a:xfrm>
+            <a:off x="9400032" y="1965960"/>
+            <a:ext cx="1828800" cy="2377440"/>
           </a:xfrm>
           <a:prstGeom prst="roundRect">
             <a:avLst>
@@ -3222,7 +3628,7 @@
           <a:solidFill>
             <a:srgbClr val="FCF7EF"/>
           </a:solidFill>
-          <a:ln w="12700">
+          <a:ln w="16510">
             <a:solidFill>
               <a:srgbClr val="E4D5C0"/>
             </a:solidFill>
@@ -3259,14 +3665,381 @@
       </p:sp>
       <p:sp>
         <p:nvSpPr>
-          <p:cNvPr id="5" name="TextBox 4"/>
+          <p:cNvPr id="14" name="Rounded Rectangle 13"/>
+          <p:cNvSpPr/>
+          <p:nvPr/>
+        </p:nvSpPr>
+        <p:spPr>
+          <a:xfrm>
+            <a:off x="10369295" y="2240280"/>
+            <a:ext cx="585216" cy="655441"/>
+          </a:xfrm>
+          <a:prstGeom prst="roundRect">
+            <a:avLst>
+              <a:gd name="adj" fmla="val 12000"/>
+            </a:avLst>
+          </a:prstGeom>
+          <a:solidFill>
+            <a:srgbClr val="5A93DE"/>
+          </a:solidFill>
+          <a:ln>
+            <a:noFill/>
+          </a:ln>
+          <a:effectLst/>
+        </p:spPr>
+        <p:style>
+          <a:lnRef idx="1">
+            <a:schemeClr val="accent1"/>
+          </a:lnRef>
+          <a:fillRef idx="3">
+            <a:schemeClr val="accent1"/>
+          </a:fillRef>
+          <a:effectRef idx="2">
+            <a:schemeClr val="accent1"/>
+          </a:effectRef>
+          <a:fontRef idx="minor">
+            <a:schemeClr val="lt1"/>
+          </a:fontRef>
+        </p:style>
+        <p:txBody>
+          <a:bodyPr rtlCol="0" anchor="ctr"/>
+          <a:lstStyle/>
+          <a:p>
+            <a:pPr algn="ctr"/>
+          </a:p>
+        </p:txBody>
+      </p:sp>
+      <p:sp>
+        <p:nvSpPr>
+          <p:cNvPr id="15" name="Oval 14"/>
+          <p:cNvSpPr/>
+          <p:nvPr/>
+        </p:nvSpPr>
+        <p:spPr>
+          <a:xfrm>
+            <a:off x="10544860" y="2322210"/>
+            <a:ext cx="234086" cy="234086"/>
+          </a:xfrm>
+          <a:prstGeom prst="ellipse">
+            <a:avLst/>
+          </a:prstGeom>
+          <a:solidFill>
+            <a:srgbClr val="FCF7EF"/>
+          </a:solidFill>
+          <a:ln>
+            <a:noFill/>
+          </a:ln>
+          <a:effectLst/>
+        </p:spPr>
+        <p:style>
+          <a:lnRef idx="1">
+            <a:schemeClr val="accent1"/>
+          </a:lnRef>
+          <a:fillRef idx="3">
+            <a:schemeClr val="accent1"/>
+          </a:fillRef>
+          <a:effectRef idx="2">
+            <a:schemeClr val="accent1"/>
+          </a:effectRef>
+          <a:fontRef idx="minor">
+            <a:schemeClr val="lt1"/>
+          </a:fontRef>
+        </p:style>
+        <p:txBody>
+          <a:bodyPr rtlCol="0" anchor="ctr"/>
+          <a:lstStyle/>
+          <a:p>
+            <a:pPr algn="ctr"/>
+          </a:p>
+        </p:txBody>
+      </p:sp>
+      <p:sp>
+        <p:nvSpPr>
+          <p:cNvPr id="16" name="Round Same Side Corner Rectangle 15"/>
+          <p:cNvSpPr/>
+          <p:nvPr/>
+        </p:nvSpPr>
+        <p:spPr>
+          <a:xfrm>
+            <a:off x="10462930" y="2579705"/>
+            <a:ext cx="397946" cy="198973"/>
+          </a:xfrm>
+          <a:prstGeom prst="round2SameRect">
+            <a:avLst>
+              <a:gd name="adj1" fmla="val 50000"/>
+              <a:gd name="adj2" fmla="val 0"/>
+            </a:avLst>
+          </a:prstGeom>
+          <a:solidFill>
+            <a:srgbClr val="FCF7EF"/>
+          </a:solidFill>
+          <a:ln>
+            <a:noFill/>
+          </a:ln>
+          <a:effectLst/>
+        </p:spPr>
+        <p:style>
+          <a:lnRef idx="1">
+            <a:schemeClr val="accent1"/>
+          </a:lnRef>
+          <a:fillRef idx="3">
+            <a:schemeClr val="accent1"/>
+          </a:fillRef>
+          <a:effectRef idx="2">
+            <a:schemeClr val="accent1"/>
+          </a:effectRef>
+          <a:fontRef idx="minor">
+            <a:schemeClr val="lt1"/>
+          </a:fontRef>
+        </p:style>
+        <p:txBody>
+          <a:bodyPr rtlCol="0" anchor="ctr"/>
+          <a:lstStyle/>
+          <a:p>
+            <a:pPr algn="ctr"/>
+          </a:p>
+        </p:txBody>
+      </p:sp>
+      <p:sp>
+        <p:nvSpPr>
+          <p:cNvPr id="17" name="Rounded Rectangle 16"/>
+          <p:cNvSpPr/>
+          <p:nvPr/>
+        </p:nvSpPr>
+        <p:spPr>
+          <a:xfrm>
+            <a:off x="9674352" y="2267712"/>
+            <a:ext cx="731520" cy="142646"/>
+          </a:xfrm>
+          <a:prstGeom prst="roundRect">
+            <a:avLst>
+              <a:gd name="adj" fmla="val 50000"/>
+            </a:avLst>
+          </a:prstGeom>
+          <a:solidFill>
+            <a:srgbClr val="5A93DE"/>
+          </a:solidFill>
+          <a:ln>
+            <a:noFill/>
+          </a:ln>
+          <a:effectLst/>
+        </p:spPr>
+        <p:style>
+          <a:lnRef idx="1">
+            <a:schemeClr val="accent1"/>
+          </a:lnRef>
+          <a:fillRef idx="3">
+            <a:schemeClr val="accent1"/>
+          </a:fillRef>
+          <a:effectRef idx="2">
+            <a:schemeClr val="accent1"/>
+          </a:effectRef>
+          <a:fontRef idx="minor">
+            <a:schemeClr val="lt1"/>
+          </a:fontRef>
+        </p:style>
+        <p:txBody>
+          <a:bodyPr rtlCol="0" anchor="ctr"/>
+          <a:lstStyle/>
+          <a:p>
+            <a:pPr algn="ctr"/>
+          </a:p>
+        </p:txBody>
+      </p:sp>
+      <p:sp>
+        <p:nvSpPr>
+          <p:cNvPr id="18" name="Rounded Rectangle 17"/>
+          <p:cNvSpPr/>
+          <p:nvPr/>
+        </p:nvSpPr>
+        <p:spPr>
+          <a:xfrm>
+            <a:off x="9674352" y="2596896"/>
+            <a:ext cx="585216" cy="106984"/>
+          </a:xfrm>
+          <a:prstGeom prst="roundRect">
+            <a:avLst>
+              <a:gd name="adj" fmla="val 50000"/>
+            </a:avLst>
+          </a:prstGeom>
+          <a:solidFill>
+            <a:srgbClr val="E4D5C0"/>
+          </a:solidFill>
+          <a:ln>
+            <a:noFill/>
+          </a:ln>
+          <a:effectLst/>
+        </p:spPr>
+        <p:style>
+          <a:lnRef idx="1">
+            <a:schemeClr val="accent1"/>
+          </a:lnRef>
+          <a:fillRef idx="3">
+            <a:schemeClr val="accent1"/>
+          </a:fillRef>
+          <a:effectRef idx="2">
+            <a:schemeClr val="accent1"/>
+          </a:effectRef>
+          <a:fontRef idx="minor">
+            <a:schemeClr val="lt1"/>
+          </a:fontRef>
+        </p:style>
+        <p:txBody>
+          <a:bodyPr rtlCol="0" anchor="ctr"/>
+          <a:lstStyle/>
+          <a:p>
+            <a:pPr algn="ctr"/>
+          </a:p>
+        </p:txBody>
+      </p:sp>
+      <p:sp>
+        <p:nvSpPr>
+          <p:cNvPr id="19" name="Rounded Rectangle 18"/>
+          <p:cNvSpPr/>
+          <p:nvPr/>
+        </p:nvSpPr>
+        <p:spPr>
+          <a:xfrm>
+            <a:off x="9674352" y="3035808"/>
+            <a:ext cx="1316736" cy="106984"/>
+          </a:xfrm>
+          <a:prstGeom prst="roundRect">
+            <a:avLst>
+              <a:gd name="adj" fmla="val 50000"/>
+            </a:avLst>
+          </a:prstGeom>
+          <a:solidFill>
+            <a:srgbClr val="E4D5C0"/>
+          </a:solidFill>
+          <a:ln>
+            <a:noFill/>
+          </a:ln>
+          <a:effectLst/>
+        </p:spPr>
+        <p:style>
+          <a:lnRef idx="1">
+            <a:schemeClr val="accent1"/>
+          </a:lnRef>
+          <a:fillRef idx="3">
+            <a:schemeClr val="accent1"/>
+          </a:fillRef>
+          <a:effectRef idx="2">
+            <a:schemeClr val="accent1"/>
+          </a:effectRef>
+          <a:fontRef idx="minor">
+            <a:schemeClr val="lt1"/>
+          </a:fontRef>
+        </p:style>
+        <p:txBody>
+          <a:bodyPr rtlCol="0" anchor="ctr"/>
+          <a:lstStyle/>
+          <a:p>
+            <a:pPr algn="ctr"/>
+          </a:p>
+        </p:txBody>
+      </p:sp>
+      <p:sp>
+        <p:nvSpPr>
+          <p:cNvPr id="20" name="Rounded Rectangle 19"/>
+          <p:cNvSpPr/>
+          <p:nvPr/>
+        </p:nvSpPr>
+        <p:spPr>
+          <a:xfrm>
+            <a:off x="9674352" y="3321100"/>
+            <a:ext cx="1170432" cy="106984"/>
+          </a:xfrm>
+          <a:prstGeom prst="roundRect">
+            <a:avLst>
+              <a:gd name="adj" fmla="val 50000"/>
+            </a:avLst>
+          </a:prstGeom>
+          <a:solidFill>
+            <a:srgbClr val="E4D5C0"/>
+          </a:solidFill>
+          <a:ln>
+            <a:noFill/>
+          </a:ln>
+          <a:effectLst/>
+        </p:spPr>
+        <p:style>
+          <a:lnRef idx="1">
+            <a:schemeClr val="accent1"/>
+          </a:lnRef>
+          <a:fillRef idx="3">
+            <a:schemeClr val="accent1"/>
+          </a:fillRef>
+          <a:effectRef idx="2">
+            <a:schemeClr val="accent1"/>
+          </a:effectRef>
+          <a:fontRef idx="minor">
+            <a:schemeClr val="lt1"/>
+          </a:fontRef>
+        </p:style>
+        <p:txBody>
+          <a:bodyPr rtlCol="0" anchor="ctr"/>
+          <a:lstStyle/>
+          <a:p>
+            <a:pPr algn="ctr"/>
+          </a:p>
+        </p:txBody>
+      </p:sp>
+      <p:sp>
+        <p:nvSpPr>
+          <p:cNvPr id="21" name="Rounded Rectangle 20"/>
+          <p:cNvSpPr/>
+          <p:nvPr/>
+        </p:nvSpPr>
+        <p:spPr>
+          <a:xfrm>
+            <a:off x="9674352" y="3606393"/>
+            <a:ext cx="1243584" cy="106984"/>
+          </a:xfrm>
+          <a:prstGeom prst="roundRect">
+            <a:avLst>
+              <a:gd name="adj" fmla="val 50000"/>
+            </a:avLst>
+          </a:prstGeom>
+          <a:solidFill>
+            <a:srgbClr val="E4D5C0"/>
+          </a:solidFill>
+          <a:ln>
+            <a:noFill/>
+          </a:ln>
+          <a:effectLst/>
+        </p:spPr>
+        <p:style>
+          <a:lnRef idx="1">
+            <a:schemeClr val="accent1"/>
+          </a:lnRef>
+          <a:fillRef idx="3">
+            <a:schemeClr val="accent1"/>
+          </a:fillRef>
+          <a:effectRef idx="2">
+            <a:schemeClr val="accent1"/>
+          </a:effectRef>
+          <a:fontRef idx="minor">
+            <a:schemeClr val="lt1"/>
+          </a:fontRef>
+        </p:style>
+        <p:txBody>
+          <a:bodyPr rtlCol="0" anchor="ctr"/>
+          <a:lstStyle/>
+          <a:p>
+            <a:pPr algn="ctr"/>
+          </a:p>
+        </p:txBody>
+      </p:sp>
+      <p:sp>
+        <p:nvSpPr>
+          <p:cNvPr id="22" name="TextBox 21"/>
           <p:cNvSpPr txBox="1"/>
           <p:nvPr/>
         </p:nvSpPr>
         <p:spPr>
           <a:xfrm>
-            <a:off x="3169767" y="1325880"/>
-            <a:ext cx="5852160" cy="1280160"/>
+            <a:off x="9400032" y="3772814"/>
+            <a:ext cx="1828800" cy="618134"/>
           </a:xfrm>
           <a:prstGeom prst="rect">
             <a:avLst/>
@@ -3285,25 +4058,7 @@
               </a:lnSpc>
             </a:pPr>
             <a:r>
-              <a:rPr sz="7192" b="0" i="0">
-                <a:solidFill>
-                  <a:srgbClr val="E96CA4"/>
-                </a:solidFill>
-                <a:latin typeface="Calibri"/>
-              </a:rPr>
-              <a:t>♀</a:t>
-            </a:r>
-            <a:r>
-              <a:rPr sz="7192" b="0" i="0">
-                <a:solidFill>
-                  <a:srgbClr val="9B8571"/>
-                </a:solidFill>
-                <a:latin typeface="Calibri"/>
-              </a:rPr>
-              <a:t>   vs   </a:t>
-            </a:r>
-            <a:r>
-              <a:rPr sz="7192" b="0" i="0">
+              <a:rPr sz="4176" b="0" i="0">
                 <a:solidFill>
                   <a:srgbClr val="5A93DE"/>
                 </a:solidFill>
@@ -3316,14 +4071,14 @@
       </p:sp>
       <p:sp>
         <p:nvSpPr>
-          <p:cNvPr id="6" name="TextBox 5"/>
+          <p:cNvPr id="23" name="TextBox 22"/>
           <p:cNvSpPr txBox="1"/>
           <p:nvPr/>
         </p:nvSpPr>
         <p:spPr>
           <a:xfrm>
-            <a:off x="518007" y="2880360"/>
-            <a:ext cx="11155680" cy="1737360"/>
+            <a:off x="2895447" y="1874519"/>
+            <a:ext cx="6400800" cy="1371600"/>
           </a:xfrm>
           <a:prstGeom prst="rect">
             <a:avLst/>
@@ -3338,11 +4093,11 @@
           <a:p>
             <a:pPr algn="ctr">
               <a:lnSpc>
-                <a:spcPct val="103000"/>
+                <a:spcPct val="104000"/>
               </a:lnSpc>
             </a:pPr>
             <a:r>
-              <a:rPr sz="4291" b="1" i="0">
+              <a:rPr sz="3944" b="1" i="0">
                 <a:solidFill>
                   <a:srgbClr val="3E2C1E"/>
                 </a:solidFill>
@@ -3351,7 +4106,7 @@
               <a:t>Gender bias when </a:t>
             </a:r>
             <a:r>
-              <a:rPr sz="4291" b="1" i="0">
+              <a:rPr sz="3944" b="1" i="0">
                 <a:solidFill>
                   <a:srgbClr val="CE5A38"/>
                 </a:solidFill>
@@ -3360,27 +4115,43 @@
               <a:t>AI</a:t>
             </a:r>
             <a:r>
-              <a:rPr sz="4291" b="1" i="0">
+              <a:rPr sz="3944" b="1" i="0">
                 <a:solidFill>
                   <a:srgbClr val="3E2C1E"/>
                 </a:solidFill>
                 <a:latin typeface="Georgia"/>
               </a:rPr>
-              <a:t> screens resumes</a:t>
+              <a:t/>
             </a:r>
           </a:p>
-        </p:txBody>
-      </p:sp>
-      <p:sp>
-        <p:nvSpPr>
-          <p:cNvPr id="7" name="TextBox 6"/>
+          <a:p>
+            <a:pPr algn="ctr">
+              <a:lnSpc>
+                <a:spcPct val="104000"/>
+              </a:lnSpc>
+            </a:pPr>
+            <a:r>
+              <a:rPr sz="3944" b="1" i="0">
+                <a:solidFill>
+                  <a:srgbClr val="3E2C1E"/>
+                </a:solidFill>
+                <a:latin typeface="Georgia"/>
+              </a:rPr>
+              <a:t>screens resumes</a:t>
+            </a:r>
+          </a:p>
+        </p:txBody>
+      </p:sp>
+      <p:sp>
+        <p:nvSpPr>
+          <p:cNvPr id="24" name="TextBox 23"/>
           <p:cNvSpPr txBox="1"/>
           <p:nvPr/>
         </p:nvSpPr>
         <p:spPr>
           <a:xfrm>
-            <a:off x="2438247" y="4800600"/>
-            <a:ext cx="7315200" cy="457200"/>
+            <a:off x="2804007" y="3749039"/>
+            <a:ext cx="6583680" cy="365760"/>
           </a:xfrm>
           <a:prstGeom prst="rect">
             <a:avLst/>
@@ -3399,7 +4170,85 @@
               </a:lnSpc>
             </a:pPr>
             <a:r>
-              <a:rPr sz="1739" b="1" i="0" spc="340">
+              <a:rPr sz="1391" b="1" i="0" spc="300">
+                <a:solidFill>
+                  <a:srgbClr val="C18150"/>
+                </a:solidFill>
+                <a:latin typeface="Calibri"/>
+              </a:rPr>
+              <a:t>BASED ON THE STUDY</a:t>
+            </a:r>
+          </a:p>
+        </p:txBody>
+      </p:sp>
+      <p:sp>
+        <p:nvSpPr>
+          <p:cNvPr id="25" name="TextBox 24"/>
+          <p:cNvSpPr txBox="1"/>
+          <p:nvPr/>
+        </p:nvSpPr>
+        <p:spPr>
+          <a:xfrm>
+            <a:off x="2712567" y="4114800"/>
+            <a:ext cx="6766560" cy="1234440"/>
+          </a:xfrm>
+          <a:prstGeom prst="rect">
+            <a:avLst/>
+          </a:prstGeom>
+          <a:noFill/>
+        </p:spPr>
+        <p:txBody>
+          <a:bodyPr wrap="square" anchor="ctr" lIns="0" rIns="0" tIns="0" bIns="0">
+            <a:spAutoFit/>
+          </a:bodyPr>
+          <a:lstStyle/>
+          <a:p>
+            <a:pPr algn="ctr">
+              <a:lnSpc>
+                <a:spcPct val="114000"/>
+              </a:lnSpc>
+            </a:pPr>
+            <a:r>
+              <a:rPr sz="1507" b="0" i="1">
+                <a:solidFill>
+                  <a:srgbClr val="3E2C1E"/>
+                </a:solidFill>
+                <a:latin typeface="Georgia"/>
+              </a:rPr>
+              <a:t>“Gender Bias in LLM Hiring Decisions: Evidence from a Japanese Context and Evaluation of Mitigation Strategies”</a:t>
+            </a:r>
+          </a:p>
+        </p:txBody>
+      </p:sp>
+      <p:sp>
+        <p:nvSpPr>
+          <p:cNvPr id="26" name="TextBox 25"/>
+          <p:cNvSpPr txBox="1"/>
+          <p:nvPr/>
+        </p:nvSpPr>
+        <p:spPr>
+          <a:xfrm>
+            <a:off x="2438247" y="5715000"/>
+            <a:ext cx="7315200" cy="411480"/>
+          </a:xfrm>
+          <a:prstGeom prst="rect">
+            <a:avLst/>
+          </a:prstGeom>
+          <a:noFill/>
+        </p:spPr>
+        <p:txBody>
+          <a:bodyPr wrap="square" anchor="ctr" lIns="0" rIns="0" tIns="0" bIns="0">
+            <a:spAutoFit/>
+          </a:bodyPr>
+          <a:lstStyle/>
+          <a:p>
+            <a:pPr algn="ctr">
+              <a:lnSpc>
+                <a:spcPct val="100000"/>
+              </a:lnSpc>
+            </a:pPr>
+            <a:r>
+              <a:rPr sz="1623" b="1" i="0" spc="300">
                 <a:solidFill>
                   <a:srgbClr val="C18150"/>
                 </a:solidFill>
@@ -3545,8 +4394,8 @@
         </p:nvSpPr>
         <p:spPr>
           <a:xfrm>
-            <a:off x="1523847" y="3749039"/>
-            <a:ext cx="9144000" cy="914400"/>
+            <a:off x="1523847" y="3703320"/>
+            <a:ext cx="9144000" cy="1005840"/>
           </a:xfrm>
           <a:prstGeom prst="rect">
             <a:avLst/>
@@ -3565,7 +4414,7 @@
               </a:lnSpc>
             </a:pPr>
             <a:r>
-              <a:rPr sz="5567" b="1" i="0">
+              <a:rPr sz="6495" b="1" i="0">
                 <a:solidFill>
                   <a:srgbClr val="3E2C1E"/>
                 </a:solidFill>
@@ -3693,8 +4542,8 @@
         </p:nvSpPr>
         <p:spPr>
           <a:xfrm>
-            <a:off x="2438247" y="566928"/>
-            <a:ext cx="7315200" cy="365760"/>
+            <a:off x="2438247" y="530352"/>
+            <a:ext cx="7315200" cy="402336"/>
           </a:xfrm>
           <a:prstGeom prst="rect">
             <a:avLst/>
@@ -3713,7 +4562,7 @@
               </a:lnSpc>
             </a:pPr>
             <a:r>
-              <a:rPr sz="1507" b="1" i="0" spc="420">
+              <a:rPr sz="1855" b="1" i="0" spc="420">
                 <a:solidFill>
                   <a:srgbClr val="C18150"/>
                 </a:solidFill>
@@ -3732,13 +4581,13 @@
         </p:nvCxnSpPr>
         <p:spPr>
           <a:xfrm>
-            <a:off x="5803239" y="987552"/>
-            <a:ext cx="585216" cy="0"/>
+            <a:off x="5730087" y="1024128"/>
+            <a:ext cx="731520" cy="0"/>
           </a:xfrm>
           <a:prstGeom prst="bentConnector3">
             <a:avLst/>
           </a:prstGeom>
-          <a:ln w="27940">
+          <a:ln w="30480">
             <a:solidFill>
               <a:srgbClr val="C18150"/>
             </a:solidFill>
@@ -3775,7 +4624,7 @@
             <a:avLst/>
           </a:prstGeom>
           <a:solidFill>
-            <a:srgbClr val="6B4A34"/>
+            <a:srgbClr val="C18150"/>
           </a:solidFill>
           <a:ln>
             <a:noFill/>
@@ -3828,7 +4677,7 @@
             </a:avLst>
           </a:prstGeom>
           <a:solidFill>
-            <a:srgbClr val="6B4A34"/>
+            <a:srgbClr val="C18150"/>
           </a:solidFill>
           <a:ln>
             <a:noFill/>
@@ -4538,9 +5387,9 @@
               </a:lnSpc>
             </a:pPr>
             <a:r>
-              <a:rPr sz="1507" b="1" i="0" spc="240">
+              <a:rPr sz="1623" b="1" i="0" spc="240">
                 <a:solidFill>
-                  <a:srgbClr val="6B4A34"/>
+                  <a:srgbClr val="C18150"/>
                 </a:solidFill>
                 <a:latin typeface="Calibri"/>
               </a:rPr>
@@ -4577,7 +5426,7 @@
               </a:lnSpc>
             </a:pPr>
             <a:r>
-              <a:rPr sz="1507" b="1" i="0" spc="240">
+              <a:rPr sz="1623" b="1" i="0" spc="240">
                 <a:solidFill>
                   <a:srgbClr val="CE5A38"/>
                 </a:solidFill>
@@ -4616,7 +5465,7 @@
               </a:lnSpc>
             </a:pPr>
             <a:r>
-              <a:rPr sz="1507" b="1" i="0" spc="240">
+              <a:rPr sz="1623" b="1" i="0" spc="240">
                 <a:solidFill>
                   <a:srgbClr val="6B4A34"/>
                 </a:solidFill>
@@ -4635,8 +5484,8 @@
         </p:nvSpPr>
         <p:spPr>
           <a:xfrm>
-            <a:off x="1158087" y="5212080"/>
-            <a:ext cx="9875520" cy="640080"/>
+            <a:off x="335127" y="5166360"/>
+            <a:ext cx="11521440" cy="731520"/>
           </a:xfrm>
           <a:prstGeom prst="rect">
             <a:avLst/>
@@ -4655,7 +5504,7 @@
               </a:lnSpc>
             </a:pPr>
             <a:r>
-              <a:rPr sz="2899" b="1" i="0">
+              <a:rPr sz="3015" b="1" i="0">
                 <a:solidFill>
                   <a:srgbClr val="3E2C1E"/>
                 </a:solidFill>
@@ -4827,8 +5676,8 @@
         </p:nvSpPr>
         <p:spPr>
           <a:xfrm>
-            <a:off x="2438247" y="566928"/>
-            <a:ext cx="7315200" cy="365760"/>
+            <a:off x="2438247" y="530352"/>
+            <a:ext cx="7315200" cy="402336"/>
           </a:xfrm>
           <a:prstGeom prst="rect">
             <a:avLst/>
@@ -4847,7 +5696,7 @@
               </a:lnSpc>
             </a:pPr>
             <a:r>
-              <a:rPr sz="1507" b="1" i="0" spc="420">
+              <a:rPr sz="1855" b="1" i="0" spc="420">
                 <a:solidFill>
                   <a:srgbClr val="C18150"/>
                 </a:solidFill>
@@ -4866,13 +5715,13 @@
         </p:nvCxnSpPr>
         <p:spPr>
           <a:xfrm>
-            <a:off x="5803239" y="987552"/>
-            <a:ext cx="585216" cy="0"/>
+            <a:off x="5730087" y="1024128"/>
+            <a:ext cx="731520" cy="0"/>
           </a:xfrm>
           <a:prstGeom prst="bentConnector3">
             <a:avLst/>
           </a:prstGeom>
-          <a:ln w="27940">
+          <a:ln w="30480">
             <a:solidFill>
               <a:srgbClr val="C18150"/>
             </a:solidFill>
@@ -5748,8 +6597,8 @@
         </p:nvSpPr>
         <p:spPr>
           <a:xfrm>
-            <a:off x="2438247" y="566928"/>
-            <a:ext cx="7315200" cy="365760"/>
+            <a:off x="2438247" y="530352"/>
+            <a:ext cx="7315200" cy="402336"/>
           </a:xfrm>
           <a:prstGeom prst="rect">
             <a:avLst/>
@@ -5768,7 +6617,7 @@
               </a:lnSpc>
             </a:pPr>
             <a:r>
-              <a:rPr sz="1507" b="1" i="0" spc="420">
+              <a:rPr sz="1855" b="1" i="0" spc="420">
                 <a:solidFill>
                   <a:srgbClr val="CE5A38"/>
                 </a:solidFill>
@@ -5787,13 +6636,13 @@
         </p:nvCxnSpPr>
         <p:spPr>
           <a:xfrm>
-            <a:off x="5803239" y="987552"/>
-            <a:ext cx="585216" cy="0"/>
+            <a:off x="5730087" y="1024128"/>
+            <a:ext cx="731520" cy="0"/>
           </a:xfrm>
           <a:prstGeom prst="bentConnector3">
             <a:avLst/>
           </a:prstGeom>
-          <a:ln w="27940">
+          <a:ln w="30480">
             <a:solidFill>
               <a:srgbClr val="CE5A38"/>
             </a:solidFill>
@@ -6258,8 +7107,8 @@
         </p:nvSpPr>
         <p:spPr>
           <a:xfrm>
-            <a:off x="975207" y="5440680"/>
-            <a:ext cx="10241280" cy="822960"/>
+            <a:off x="335127" y="5394960"/>
+            <a:ext cx="11521440" cy="822960"/>
           </a:xfrm>
           <a:prstGeom prst="rect">
             <a:avLst/>
@@ -6278,7 +7127,7 @@
               </a:lnSpc>
             </a:pPr>
             <a:r>
-              <a:rPr sz="2783" b="1" i="0">
+              <a:rPr sz="3015" b="1" i="0">
                 <a:solidFill>
                   <a:srgbClr val="3E2C1E"/>
                 </a:solidFill>
@@ -6450,8 +7299,8 @@
         </p:nvSpPr>
         <p:spPr>
           <a:xfrm>
-            <a:off x="2438247" y="566928"/>
-            <a:ext cx="7315200" cy="365760"/>
+            <a:off x="2438247" y="530352"/>
+            <a:ext cx="7315200" cy="402336"/>
           </a:xfrm>
           <a:prstGeom prst="rect">
             <a:avLst/>
@@ -6470,7 +7319,7 @@
               </a:lnSpc>
             </a:pPr>
             <a:r>
-              <a:rPr sz="1507" b="1" i="0" spc="420">
+              <a:rPr sz="1855" b="1" i="0" spc="420">
                 <a:solidFill>
                   <a:srgbClr val="C18150"/>
                 </a:solidFill>
@@ -6489,13 +7338,13 @@
         </p:nvCxnSpPr>
         <p:spPr>
           <a:xfrm>
-            <a:off x="5803239" y="987552"/>
-            <a:ext cx="585216" cy="0"/>
+            <a:off x="5730087" y="1024128"/>
+            <a:ext cx="731520" cy="0"/>
           </a:xfrm>
           <a:prstGeom prst="bentConnector3">
             <a:avLst/>
           </a:prstGeom>
-          <a:ln w="27940">
+          <a:ln w="30480">
             <a:solidFill>
               <a:srgbClr val="C18150"/>
             </a:solidFill>
@@ -7484,8 +8333,8 @@
         </p:nvSpPr>
         <p:spPr>
           <a:xfrm>
-            <a:off x="975207" y="4572000"/>
-            <a:ext cx="10241280" cy="548640"/>
+            <a:off x="335127" y="4572000"/>
+            <a:ext cx="11521440" cy="548640"/>
           </a:xfrm>
           <a:prstGeom prst="rect">
             <a:avLst/>
@@ -7504,7 +8353,7 @@
               </a:lnSpc>
             </a:pPr>
             <a:r>
-              <a:rPr sz="2783" b="1" i="0">
+              <a:rPr sz="3015" b="1" i="0">
                 <a:solidFill>
                   <a:srgbClr val="3E2C1E"/>
                 </a:solidFill>
@@ -8400,8 +9249,8 @@
         </p:nvSpPr>
         <p:spPr>
           <a:xfrm>
-            <a:off x="2438247" y="566928"/>
-            <a:ext cx="7315200" cy="365760"/>
+            <a:off x="2438247" y="530352"/>
+            <a:ext cx="7315200" cy="402336"/>
           </a:xfrm>
           <a:prstGeom prst="rect">
             <a:avLst/>
@@ -8420,7 +9269,7 @@
               </a:lnSpc>
             </a:pPr>
             <a:r>
-              <a:rPr sz="1507" b="1" i="0" spc="420">
+              <a:rPr sz="1855" b="1" i="0" spc="420">
                 <a:solidFill>
                   <a:srgbClr val="CE5A38"/>
                 </a:solidFill>
@@ -8439,13 +9288,13 @@
         </p:nvCxnSpPr>
         <p:spPr>
           <a:xfrm>
-            <a:off x="5803239" y="987552"/>
-            <a:ext cx="585216" cy="0"/>
+            <a:off x="5730087" y="1024128"/>
+            <a:ext cx="731520" cy="0"/>
           </a:xfrm>
           <a:prstGeom prst="bentConnector3">
             <a:avLst/>
           </a:prstGeom>
-          <a:ln w="27940">
+          <a:ln w="30480">
             <a:solidFill>
               <a:srgbClr val="CE5A38"/>
             </a:solidFill>
@@ -9564,8 +10413,8 @@
         </p:nvSpPr>
         <p:spPr>
           <a:xfrm>
-            <a:off x="700887" y="5623560"/>
-            <a:ext cx="10789920" cy="731520"/>
+            <a:off x="243687" y="5577840"/>
+            <a:ext cx="11704320" cy="822960"/>
           </a:xfrm>
           <a:prstGeom prst="rect">
             <a:avLst/>
@@ -9584,7 +10433,7 @@
               </a:lnSpc>
             </a:pPr>
             <a:r>
-              <a:rPr sz="2899" b="1" i="0">
+              <a:rPr sz="3015" b="1" i="0">
                 <a:solidFill>
                   <a:srgbClr val="3E2C1E"/>
                 </a:solidFill>
@@ -9593,7 +10442,7 @@
               <a:t>Female names scored </a:t>
             </a:r>
             <a:r>
-              <a:rPr sz="2899" b="1" i="0">
+              <a:rPr sz="3015" b="1" i="0">
                 <a:solidFill>
                   <a:srgbClr val="E96CA4"/>
                 </a:solidFill>
@@ -9602,7 +10451,7 @@
               <a:t>slightly higher</a:t>
             </a:r>
             <a:r>
-              <a:rPr sz="2899" b="1" i="0">
+              <a:rPr sz="3015" b="1" i="0">
                 <a:solidFill>
                   <a:srgbClr val="3E2C1E"/>
                 </a:solidFill>
@@ -9774,8 +10623,8 @@
         </p:nvSpPr>
         <p:spPr>
           <a:xfrm>
-            <a:off x="2438247" y="566928"/>
-            <a:ext cx="7315200" cy="365760"/>
+            <a:off x="2438247" y="530352"/>
+            <a:ext cx="7315200" cy="402336"/>
           </a:xfrm>
           <a:prstGeom prst="rect">
             <a:avLst/>
@@ -9794,7 +10643,7 @@
               </a:lnSpc>
             </a:pPr>
             <a:r>
-              <a:rPr sz="1507" b="1" i="0" spc="420">
+              <a:rPr sz="1855" b="1" i="0" spc="420">
                 <a:solidFill>
                   <a:srgbClr val="DCA62A"/>
                 </a:solidFill>
@@ -9813,13 +10662,13 @@
         </p:nvCxnSpPr>
         <p:spPr>
           <a:xfrm>
-            <a:off x="5803239" y="987552"/>
-            <a:ext cx="585216" cy="0"/>
+            <a:off x="5730087" y="1024128"/>
+            <a:ext cx="731520" cy="0"/>
           </a:xfrm>
           <a:prstGeom prst="bentConnector3">
             <a:avLst/>
           </a:prstGeom>
-          <a:ln w="27940">
+          <a:ln w="30480">
             <a:solidFill>
               <a:srgbClr val="DCA62A"/>
             </a:solidFill>
@@ -10725,8 +11574,8 @@
         </p:nvSpPr>
         <p:spPr>
           <a:xfrm>
-            <a:off x="700887" y="5440680"/>
-            <a:ext cx="10789920" cy="640080"/>
+            <a:off x="518007" y="5440680"/>
+            <a:ext cx="11155680" cy="640080"/>
           </a:xfrm>
           <a:prstGeom prst="rect">
             <a:avLst/>
@@ -10745,7 +11594,7 @@
               </a:lnSpc>
             </a:pPr>
             <a:r>
-              <a:rPr sz="2899" b="1" i="0">
+              <a:rPr sz="3247" b="1" i="0">
                 <a:solidFill>
                   <a:srgbClr val="3E2C1E"/>
                 </a:solidFill>
@@ -10917,8 +11766,8 @@
         </p:nvSpPr>
         <p:spPr>
           <a:xfrm>
-            <a:off x="2438247" y="566928"/>
-            <a:ext cx="7315200" cy="365760"/>
+            <a:off x="2438247" y="530352"/>
+            <a:ext cx="7315200" cy="402336"/>
           </a:xfrm>
           <a:prstGeom prst="rect">
             <a:avLst/>
@@ -10937,7 +11786,7 @@
               </a:lnSpc>
             </a:pPr>
             <a:r>
-              <a:rPr sz="1507" b="1" i="0" spc="420">
+              <a:rPr sz="1855" b="1" i="0" spc="420">
                 <a:solidFill>
                   <a:srgbClr val="C18150"/>
                 </a:solidFill>
@@ -10956,13 +11805,13 @@
         </p:nvCxnSpPr>
         <p:spPr>
           <a:xfrm>
-            <a:off x="5803239" y="987552"/>
-            <a:ext cx="585216" cy="0"/>
+            <a:off x="5730087" y="1024128"/>
+            <a:ext cx="731520" cy="0"/>
           </a:xfrm>
           <a:prstGeom prst="bentConnector3">
             <a:avLst/>
           </a:prstGeom>
-          <a:ln w="27940">
+          <a:ln w="30480">
             <a:solidFill>
               <a:srgbClr val="C18150"/>
             </a:solidFill>
@@ -11388,8 +12237,8 @@
         </p:nvSpPr>
         <p:spPr>
           <a:xfrm>
-            <a:off x="518007" y="5486400"/>
-            <a:ext cx="11155680" cy="868680"/>
+            <a:off x="518007" y="5166360"/>
+            <a:ext cx="11155680" cy="1234440"/>
           </a:xfrm>
           <a:prstGeom prst="rect">
             <a:avLst/>
@@ -11404,17 +12253,33 @@
           <a:p>
             <a:pPr algn="ctr">
               <a:lnSpc>
-                <a:spcPct val="104000"/>
+                <a:spcPct val="106000"/>
               </a:lnSpc>
             </a:pPr>
             <a:r>
-              <a:rPr sz="2668" b="1" i="0">
+              <a:rPr sz="3131" b="1" i="0">
                 <a:solidFill>
                   <a:srgbClr val="3E2C1E"/>
                 </a:solidFill>
                 <a:latin typeface="Georgia"/>
               </a:rPr>
-              <a:t>Fairness training may over-correct — tipping toward women</a:t>
+              <a:t>Fairness training may over-correct —</a:t>
+            </a:r>
+          </a:p>
+          <a:p>
+            <a:pPr algn="ctr">
+              <a:lnSpc>
+                <a:spcPct val="106000"/>
+              </a:lnSpc>
+            </a:pPr>
+            <a:r>
+              <a:rPr sz="3131" b="1" i="0">
+                <a:solidFill>
+                  <a:srgbClr val="3E2C1E"/>
+                </a:solidFill>
+                <a:latin typeface="Georgia"/>
+              </a:rPr>
+              <a:t>tipping toward women</a:t>
             </a:r>
           </a:p>
         </p:txBody>
@@ -11580,8 +12445,8 @@
         </p:nvSpPr>
         <p:spPr>
           <a:xfrm>
-            <a:off x="2438247" y="566928"/>
-            <a:ext cx="7315200" cy="365760"/>
+            <a:off x="2438247" y="530352"/>
+            <a:ext cx="7315200" cy="402336"/>
           </a:xfrm>
           <a:prstGeom prst="rect">
             <a:avLst/>
@@ -11600,7 +12465,7 @@
               </a:lnSpc>
             </a:pPr>
             <a:r>
-              <a:rPr sz="1507" b="1" i="0" spc="420">
+              <a:rPr sz="1855" b="1" i="0" spc="420">
                 <a:solidFill>
                   <a:srgbClr val="C18150"/>
                 </a:solidFill>
@@ -11619,13 +12484,13 @@
         </p:nvCxnSpPr>
         <p:spPr>
           <a:xfrm>
-            <a:off x="5803239" y="987552"/>
-            <a:ext cx="585216" cy="0"/>
+            <a:off x="5730087" y="1024128"/>
+            <a:ext cx="731520" cy="0"/>
           </a:xfrm>
           <a:prstGeom prst="bentConnector3">
             <a:avLst/>
           </a:prstGeom>
-          <a:ln w="27940">
+          <a:ln w="30480">
             <a:solidFill>
               <a:srgbClr val="C18150"/>
             </a:solidFill>
@@ -11655,8 +12520,8 @@
         </p:nvSpPr>
         <p:spPr>
           <a:xfrm>
-            <a:off x="700887" y="2286000"/>
-            <a:ext cx="10789920" cy="2011680"/>
+            <a:off x="335127" y="2194560"/>
+            <a:ext cx="11521440" cy="2103120"/>
           </a:xfrm>
           <a:prstGeom prst="rect">
             <a:avLst/>
@@ -11675,7 +12540,7 @@
               </a:lnSpc>
             </a:pPr>
             <a:r>
-              <a:rPr sz="3827" b="1" i="0">
+              <a:rPr sz="4291" b="1" i="0">
                 <a:solidFill>
                   <a:srgbClr val="3E2C1E"/>
                 </a:solidFill>
@@ -11691,7 +12556,7 @@
               </a:lnSpc>
             </a:pPr>
             <a:r>
-              <a:rPr sz="3827" b="1" i="0">
+              <a:rPr sz="4291" b="1" i="0">
                 <a:solidFill>
                   <a:srgbClr val="3E2C1E"/>
                 </a:solidFill>
@@ -11700,7 +12565,7 @@
               <a:t/>
             </a:r>
             <a:r>
-              <a:rPr sz="3827" b="1" i="0">
+              <a:rPr sz="4291" b="1" i="0">
                 <a:solidFill>
                   <a:srgbClr val="CE5A38"/>
                 </a:solidFill>
@@ -11719,8 +12584,8 @@
         </p:nvSpPr>
         <p:spPr>
           <a:xfrm>
-            <a:off x="1066647" y="4892040"/>
-            <a:ext cx="10058400" cy="640080"/>
+            <a:off x="883767" y="4937760"/>
+            <a:ext cx="10424160" cy="640080"/>
           </a:xfrm>
           <a:prstGeom prst="rect">
             <a:avLst/>
@@ -11739,7 +12604,7 @@
               </a:lnSpc>
             </a:pPr>
             <a:r>
-              <a:rPr sz="2320" b="1" i="1">
+              <a:rPr sz="2668" b="1" i="1">
                 <a:solidFill>
                   <a:srgbClr val="C18150"/>
                 </a:solidFill>

</xml_diff>

<commit_message>
Add full citation on final slide; bigger headings; center LLM slide
- Thank-you slide now shows the full APA-style citation (authors, 2026,
  title, arXiv:2606.18649) under a SOURCE label
- Enlarged all slide headings/eyebrows; long headings wrap to two lines
- Re-centered the LLM-training icons (were left of center)

Co-Authored-By: Claude Opus 4.8 <noreply@anthropic.com>
Claude-Session: https://claude.ai/code/session_01CjyAZ3oyttzTdGPrNqWN3p
</commit_message>
<xml_diff>
--- a/presentation/gender_bias_llm_hiring.pptx
+++ b/presentation/gender_bias_llm_hiring.pptx
@@ -4077,8 +4077,8 @@
         </p:nvSpPr>
         <p:spPr>
           <a:xfrm>
-            <a:off x="2895447" y="1874519"/>
-            <a:ext cx="6400800" cy="1371600"/>
+            <a:off x="2804007" y="1828800"/>
+            <a:ext cx="6583680" cy="1463040"/>
           </a:xfrm>
           <a:prstGeom prst="rect">
             <a:avLst/>
@@ -4097,7 +4097,7 @@
               </a:lnSpc>
             </a:pPr>
             <a:r>
-              <a:rPr sz="3944" b="1" i="0">
+              <a:rPr sz="4523" b="1" i="0">
                 <a:solidFill>
                   <a:srgbClr val="3E2C1E"/>
                 </a:solidFill>
@@ -4106,7 +4106,7 @@
               <a:t>Gender bias when </a:t>
             </a:r>
             <a:r>
-              <a:rPr sz="3944" b="1" i="0">
+              <a:rPr sz="4523" b="1" i="0">
                 <a:solidFill>
                   <a:srgbClr val="CE5A38"/>
                 </a:solidFill>
@@ -4115,7 +4115,7 @@
               <a:t>AI</a:t>
             </a:r>
             <a:r>
-              <a:rPr sz="3944" b="1" i="0">
+              <a:rPr sz="4523" b="1" i="0">
                 <a:solidFill>
                   <a:srgbClr val="3E2C1E"/>
                 </a:solidFill>
@@ -4131,7 +4131,7 @@
               </a:lnSpc>
             </a:pPr>
             <a:r>
-              <a:rPr sz="3944" b="1" i="0">
+              <a:rPr sz="4523" b="1" i="0">
                 <a:solidFill>
                   <a:srgbClr val="3E2C1E"/>
                 </a:solidFill>
@@ -4337,8 +4337,8 @@
         </p:nvSpPr>
         <p:spPr>
           <a:xfrm>
-            <a:off x="3169767" y="2468880"/>
-            <a:ext cx="5852160" cy="1280160"/>
+            <a:off x="3169767" y="2057400"/>
+            <a:ext cx="5852160" cy="1188720"/>
           </a:xfrm>
           <a:prstGeom prst="rect">
             <a:avLst/>
@@ -4357,7 +4357,7 @@
               </a:lnSpc>
             </a:pPr>
             <a:r>
-              <a:rPr sz="6728" b="0" i="0">
+              <a:rPr sz="6263" b="0" i="0">
                 <a:solidFill>
                   <a:srgbClr val="E96CA4"/>
                 </a:solidFill>
@@ -4366,7 +4366,7 @@
               <a:t>♀</a:t>
             </a:r>
             <a:r>
-              <a:rPr sz="6728" b="0" i="0">
+              <a:rPr sz="6263" b="0" i="0">
                 <a:solidFill>
                   <a:srgbClr val="3E2C1E"/>
                 </a:solidFill>
@@ -4375,7 +4375,7 @@
               <a:t>    </a:t>
             </a:r>
             <a:r>
-              <a:rPr sz="6728" b="0" i="0">
+              <a:rPr sz="6263" b="0" i="0">
                 <a:solidFill>
                   <a:srgbClr val="5A93DE"/>
                 </a:solidFill>
@@ -4394,7 +4394,7 @@
         </p:nvSpPr>
         <p:spPr>
           <a:xfrm>
-            <a:off x="1523847" y="3703320"/>
+            <a:off x="1523847" y="3154680"/>
             <a:ext cx="9144000" cy="1005840"/>
           </a:xfrm>
           <a:prstGeom prst="rect">
@@ -4414,7 +4414,7 @@
               </a:lnSpc>
             </a:pPr>
             <a:r>
-              <a:rPr sz="6495" b="1" i="0">
+              <a:rPr sz="6959" b="1" i="0">
                 <a:solidFill>
                   <a:srgbClr val="3E2C1E"/>
                 </a:solidFill>
@@ -4425,16 +4425,52 @@
           </a:p>
         </p:txBody>
       </p:sp>
-      <p:sp>
-        <p:nvSpPr>
-          <p:cNvPr id="5" name="TextBox 4"/>
+      <p:cxnSp>
+        <p:nvCxnSpPr>
+          <p:cNvPr id="5" name="Connector 4"/>
+          <p:cNvCxnSpPr/>
+          <p:nvPr/>
+        </p:nvCxnSpPr>
+        <p:spPr>
+          <a:xfrm>
+            <a:off x="5181447" y="4526280"/>
+            <a:ext cx="1828800" cy="0"/>
+          </a:xfrm>
+          <a:prstGeom prst="bentConnector3">
+            <a:avLst/>
+          </a:prstGeom>
+          <a:ln w="25400">
+            <a:solidFill>
+              <a:srgbClr val="C18150"/>
+            </a:solidFill>
+          </a:ln>
+          <a:effectLst/>
+        </p:spPr>
+        <p:style>
+          <a:lnRef idx="2">
+            <a:schemeClr val="accent1"/>
+          </a:lnRef>
+          <a:fillRef idx="0">
+            <a:schemeClr val="accent1"/>
+          </a:fillRef>
+          <a:effectRef idx="1">
+            <a:schemeClr val="accent1"/>
+          </a:effectRef>
+          <a:fontRef idx="minor">
+            <a:schemeClr val="tx1"/>
+          </a:fontRef>
+        </p:style>
+      </p:cxnSp>
+      <p:sp>
+        <p:nvSpPr>
+          <p:cNvPr id="6" name="TextBox 5"/>
           <p:cNvSpPr txBox="1"/>
           <p:nvPr/>
         </p:nvSpPr>
         <p:spPr>
           <a:xfrm>
-            <a:off x="1066647" y="4800600"/>
-            <a:ext cx="10058400" cy="457200"/>
+            <a:off x="2438247" y="4709160"/>
+            <a:ext cx="7315200" cy="365760"/>
           </a:xfrm>
           <a:prstGeom prst="rect">
             <a:avLst/>
@@ -4453,13 +4489,68 @@
               </a:lnSpc>
             </a:pPr>
             <a:r>
-              <a:rPr sz="1623" b="1" i="0" spc="160">
+              <a:rPr sz="1391" b="1" i="0" spc="320">
                 <a:solidFill>
                   <a:srgbClr val="C18150"/>
                 </a:solidFill>
                 <a:latin typeface="Calibri"/>
               </a:rPr>
-              <a:t>Gender Bias in LLM Hiring Decisions  ·  Evidence from Japan</a:t>
+              <a:t>SOURCE</a:t>
+            </a:r>
+          </a:p>
+        </p:txBody>
+      </p:sp>
+      <p:sp>
+        <p:nvSpPr>
+          <p:cNvPr id="7" name="TextBox 6"/>
+          <p:cNvSpPr txBox="1"/>
+          <p:nvPr/>
+        </p:nvSpPr>
+        <p:spPr>
+          <a:xfrm>
+            <a:off x="426567" y="5029200"/>
+            <a:ext cx="11338560" cy="1143000"/>
+          </a:xfrm>
+          <a:prstGeom prst="rect">
+            <a:avLst/>
+          </a:prstGeom>
+          <a:noFill/>
+        </p:spPr>
+        <p:txBody>
+          <a:bodyPr wrap="square" anchor="ctr" lIns="0" rIns="0" tIns="0" bIns="0">
+            <a:spAutoFit/>
+          </a:bodyPr>
+          <a:lstStyle/>
+          <a:p>
+            <a:pPr algn="ctr">
+              <a:lnSpc>
+                <a:spcPct val="125000"/>
+              </a:lnSpc>
+            </a:pPr>
+            <a:r>
+              <a:rPr sz="1391" b="0" i="1">
+                <a:solidFill>
+                  <a:srgbClr val="5A4433"/>
+                </a:solidFill>
+                <a:latin typeface="Georgia"/>
+              </a:rPr>
+              <a:t>Hoffstedde, S. A., Hirota, M., Nadayanur Sathis Kanna, A., Kotani, R., Kumar, U., Trovato, G., &amp; Tan, P. X. (2026).</a:t>
+            </a:r>
+          </a:p>
+          <a:p>
+            <a:pPr algn="ctr">
+              <a:lnSpc>
+                <a:spcPct val="125000"/>
+              </a:lnSpc>
+            </a:pPr>
+            <a:r>
+              <a:rPr sz="1391" b="0" i="1">
+                <a:solidFill>
+                  <a:srgbClr val="5A4433"/>
+                </a:solidFill>
+                <a:latin typeface="Georgia"/>
+              </a:rPr>
+              <a:t>Gender Bias in LLM Hiring Decisions: Evidence from a Japanese Context and Evaluation of Mitigation Strategies. arXiv:2606.18649.</a:t>
             </a:r>
           </a:p>
         </p:txBody>
@@ -4542,8 +4633,8 @@
         </p:nvSpPr>
         <p:spPr>
           <a:xfrm>
-            <a:off x="2438247" y="530352"/>
-            <a:ext cx="7315200" cy="402336"/>
+            <a:off x="2438247" y="512064"/>
+            <a:ext cx="7315200" cy="420624"/>
           </a:xfrm>
           <a:prstGeom prst="rect">
             <a:avLst/>
@@ -4562,7 +4653,7 @@
               </a:lnSpc>
             </a:pPr>
             <a:r>
-              <a:rPr sz="1855" b="1" i="0" spc="420">
+              <a:rPr sz="2088" b="1" i="0" spc="420">
                 <a:solidFill>
                   <a:srgbClr val="C18150"/>
                 </a:solidFill>
@@ -4581,13 +4672,13 @@
         </p:nvCxnSpPr>
         <p:spPr>
           <a:xfrm>
-            <a:off x="5730087" y="1024128"/>
-            <a:ext cx="731520" cy="0"/>
+            <a:off x="5684367" y="1042415"/>
+            <a:ext cx="822960" cy="0"/>
           </a:xfrm>
           <a:prstGeom prst="bentConnector3">
             <a:avLst/>
           </a:prstGeom>
-          <a:ln w="30480">
+          <a:ln w="33020">
             <a:solidFill>
               <a:srgbClr val="C18150"/>
             </a:solidFill>
@@ -5484,8 +5575,8 @@
         </p:nvSpPr>
         <p:spPr>
           <a:xfrm>
-            <a:off x="335127" y="5166360"/>
-            <a:ext cx="11521440" cy="731520"/>
+            <a:off x="335127" y="5029200"/>
+            <a:ext cx="11521440" cy="1005840"/>
           </a:xfrm>
           <a:prstGeom prst="rect">
             <a:avLst/>
@@ -5500,17 +5591,33 @@
           <a:p>
             <a:pPr algn="ctr">
               <a:lnSpc>
-                <a:spcPct val="100000"/>
+                <a:spcPct val="106000"/>
               </a:lnSpc>
             </a:pPr>
             <a:r>
-              <a:rPr sz="3015" b="1" i="0">
+              <a:rPr sz="3479" b="1" i="0">
                 <a:solidFill>
                   <a:srgbClr val="3E2C1E"/>
                 </a:solidFill>
                 <a:latin typeface="Georgia"/>
               </a:rPr>
-              <a:t>AI screens your resume before a human ever sees it</a:t>
+              <a:t>AI screens your resume</a:t>
+            </a:r>
+          </a:p>
+          <a:p>
+            <a:pPr algn="ctr">
+              <a:lnSpc>
+                <a:spcPct val="106000"/>
+              </a:lnSpc>
+            </a:pPr>
+            <a:r>
+              <a:rPr sz="3479" b="1" i="0">
+                <a:solidFill>
+                  <a:srgbClr val="3E2C1E"/>
+                </a:solidFill>
+                <a:latin typeface="Georgia"/>
+              </a:rPr>
+              <a:t>before a human ever sees it</a:t>
             </a:r>
           </a:p>
         </p:txBody>
@@ -5676,8 +5783,8 @@
         </p:nvSpPr>
         <p:spPr>
           <a:xfrm>
-            <a:off x="2438247" y="530352"/>
-            <a:ext cx="7315200" cy="402336"/>
+            <a:off x="2438247" y="512064"/>
+            <a:ext cx="7315200" cy="420624"/>
           </a:xfrm>
           <a:prstGeom prst="rect">
             <a:avLst/>
@@ -5696,7 +5803,7 @@
               </a:lnSpc>
             </a:pPr>
             <a:r>
-              <a:rPr sz="1855" b="1" i="0" spc="420">
+              <a:rPr sz="2088" b="1" i="0" spc="420">
                 <a:solidFill>
                   <a:srgbClr val="C18150"/>
                 </a:solidFill>
@@ -5715,13 +5822,13 @@
         </p:nvCxnSpPr>
         <p:spPr>
           <a:xfrm>
-            <a:off x="5730087" y="1024128"/>
-            <a:ext cx="731520" cy="0"/>
+            <a:off x="5684367" y="1042415"/>
+            <a:ext cx="822960" cy="0"/>
           </a:xfrm>
           <a:prstGeom prst="bentConnector3">
             <a:avLst/>
           </a:prstGeom>
-          <a:ln w="30480">
+          <a:ln w="33020">
             <a:solidFill>
               <a:srgbClr val="C18150"/>
             </a:solidFill>
@@ -5751,7 +5858,7 @@
         </p:nvSpPr>
         <p:spPr>
           <a:xfrm>
-            <a:off x="2446020" y="2631186"/>
+            <a:off x="3268979" y="2631186"/>
             <a:ext cx="1874519" cy="374904"/>
           </a:xfrm>
           <a:prstGeom prst="roundRect">
@@ -5805,7 +5912,7 @@
         </p:nvSpPr>
         <p:spPr>
           <a:xfrm>
-            <a:off x="2595981" y="2743657"/>
+            <a:off x="3418941" y="2743657"/>
             <a:ext cx="299923" cy="149961"/>
           </a:xfrm>
           <a:prstGeom prst="roundRect">
@@ -5851,7 +5958,7 @@
         </p:nvSpPr>
         <p:spPr>
           <a:xfrm>
-            <a:off x="2446020" y="3193541"/>
+            <a:off x="3268979" y="3193541"/>
             <a:ext cx="1874519" cy="374904"/>
           </a:xfrm>
           <a:prstGeom prst="roundRect">
@@ -5905,7 +6012,7 @@
         </p:nvSpPr>
         <p:spPr>
           <a:xfrm>
-            <a:off x="2595981" y="3306013"/>
+            <a:off x="3418941" y="3306013"/>
             <a:ext cx="299923" cy="149961"/>
           </a:xfrm>
           <a:prstGeom prst="roundRect">
@@ -5951,7 +6058,7 @@
         </p:nvSpPr>
         <p:spPr>
           <a:xfrm>
-            <a:off x="2446020" y="3755898"/>
+            <a:off x="3268979" y="3755898"/>
             <a:ext cx="1874519" cy="374904"/>
           </a:xfrm>
           <a:prstGeom prst="roundRect">
@@ -6005,7 +6112,7 @@
         </p:nvSpPr>
         <p:spPr>
           <a:xfrm>
-            <a:off x="2595981" y="3868369"/>
+            <a:off x="3418941" y="3868369"/>
             <a:ext cx="299923" cy="149961"/>
           </a:xfrm>
           <a:prstGeom prst="roundRect">
@@ -6051,7 +6158,7 @@
         </p:nvSpPr>
         <p:spPr>
           <a:xfrm>
-            <a:off x="4823459" y="3310127"/>
+            <a:off x="5616244" y="3310127"/>
             <a:ext cx="960120" cy="329184"/>
           </a:xfrm>
           <a:prstGeom prst="rightArrow">
@@ -6098,7 +6205,7 @@
         </p:nvCxnSpPr>
         <p:spPr>
           <a:xfrm>
-            <a:off x="7452360" y="2542946"/>
+            <a:off x="8001000" y="2542946"/>
             <a:ext cx="0" cy="237744"/>
           </a:xfrm>
           <a:prstGeom prst="bentConnector3">
@@ -6134,7 +6241,7 @@
         </p:nvSpPr>
         <p:spPr>
           <a:xfrm>
-            <a:off x="7370064" y="2396642"/>
+            <a:off x="7918704" y="2396642"/>
             <a:ext cx="164592" cy="164592"/>
           </a:xfrm>
           <a:prstGeom prst="ellipse">
@@ -6178,7 +6285,7 @@
         </p:nvSpPr>
         <p:spPr>
           <a:xfrm>
-            <a:off x="6583680" y="2780690"/>
+            <a:off x="7132320" y="2780690"/>
             <a:ext cx="1737360" cy="1424635"/>
           </a:xfrm>
           <a:prstGeom prst="roundRect">
@@ -6232,7 +6339,7 @@
         </p:nvSpPr>
         <p:spPr>
           <a:xfrm>
-            <a:off x="6939838" y="3407529"/>
+            <a:off x="7488478" y="3407529"/>
             <a:ext cx="260603" cy="260603"/>
           </a:xfrm>
           <a:prstGeom prst="ellipse">
@@ -6276,7 +6383,7 @@
         </p:nvSpPr>
         <p:spPr>
           <a:xfrm>
-            <a:off x="7704277" y="3407529"/>
+            <a:off x="8252917" y="3407529"/>
             <a:ext cx="260603" cy="260603"/>
           </a:xfrm>
           <a:prstGeom prst="ellipse">
@@ -6320,7 +6427,7 @@
         </p:nvSpPr>
         <p:spPr>
           <a:xfrm>
-            <a:off x="7104888" y="3777935"/>
+            <a:off x="7653527" y="3777935"/>
             <a:ext cx="694944" cy="99724"/>
           </a:xfrm>
           <a:prstGeom prst="roundRect">
@@ -6366,7 +6473,7 @@
         </p:nvSpPr>
         <p:spPr>
           <a:xfrm>
-            <a:off x="1828800" y="5029200"/>
+            <a:off x="2651760" y="5029200"/>
             <a:ext cx="3108960" cy="457200"/>
           </a:xfrm>
           <a:prstGeom prst="rect">
@@ -6405,7 +6512,7 @@
         </p:nvSpPr>
         <p:spPr>
           <a:xfrm>
-            <a:off x="5897880" y="5029200"/>
+            <a:off x="6446520" y="5029200"/>
             <a:ext cx="3108960" cy="457200"/>
           </a:xfrm>
           <a:prstGeom prst="rect">
@@ -6597,8 +6704,8 @@
         </p:nvSpPr>
         <p:spPr>
           <a:xfrm>
-            <a:off x="2438247" y="530352"/>
-            <a:ext cx="7315200" cy="402336"/>
+            <a:off x="2438247" y="512064"/>
+            <a:ext cx="7315200" cy="420624"/>
           </a:xfrm>
           <a:prstGeom prst="rect">
             <a:avLst/>
@@ -6617,7 +6724,7 @@
               </a:lnSpc>
             </a:pPr>
             <a:r>
-              <a:rPr sz="1855" b="1" i="0" spc="420">
+              <a:rPr sz="2088" b="1" i="0" spc="420">
                 <a:solidFill>
                   <a:srgbClr val="CE5A38"/>
                 </a:solidFill>
@@ -6636,13 +6743,13 @@
         </p:nvCxnSpPr>
         <p:spPr>
           <a:xfrm>
-            <a:off x="5730087" y="1024128"/>
-            <a:ext cx="731520" cy="0"/>
+            <a:off x="5684367" y="1042415"/>
+            <a:ext cx="822960" cy="0"/>
           </a:xfrm>
           <a:prstGeom prst="bentConnector3">
             <a:avLst/>
           </a:prstGeom>
-          <a:ln w="30480">
+          <a:ln w="33020">
             <a:solidFill>
               <a:srgbClr val="CE5A38"/>
             </a:solidFill>
@@ -7107,8 +7214,8 @@
         </p:nvSpPr>
         <p:spPr>
           <a:xfrm>
-            <a:off x="335127" y="5394960"/>
-            <a:ext cx="11521440" cy="822960"/>
+            <a:off x="335127" y="5166360"/>
+            <a:ext cx="11521440" cy="1005840"/>
           </a:xfrm>
           <a:prstGeom prst="rect">
             <a:avLst/>
@@ -7123,17 +7230,33 @@
           <a:p>
             <a:pPr algn="ctr">
               <a:lnSpc>
-                <a:spcPct val="100000"/>
+                <a:spcPct val="106000"/>
               </a:lnSpc>
             </a:pPr>
             <a:r>
-              <a:rPr sz="3015" b="1" i="0">
+              <a:rPr sz="3479" b="1" i="0">
                 <a:solidFill>
                   <a:srgbClr val="3E2C1E"/>
                 </a:solidFill>
                 <a:latin typeface="Georgia"/>
               </a:rPr>
-              <a:t>If AI learns from people, could it learn our bias?</a:t>
+              <a:t>If AI learns from people,</a:t>
+            </a:r>
+          </a:p>
+          <a:p>
+            <a:pPr algn="ctr">
+              <a:lnSpc>
+                <a:spcPct val="106000"/>
+              </a:lnSpc>
+            </a:pPr>
+            <a:r>
+              <a:rPr sz="3479" b="1" i="0">
+                <a:solidFill>
+                  <a:srgbClr val="3E2C1E"/>
+                </a:solidFill>
+                <a:latin typeface="Georgia"/>
+              </a:rPr>
+              <a:t>could it learn our bias?</a:t>
             </a:r>
           </a:p>
         </p:txBody>
@@ -7299,8 +7422,8 @@
         </p:nvSpPr>
         <p:spPr>
           <a:xfrm>
-            <a:off x="2438247" y="530352"/>
-            <a:ext cx="7315200" cy="402336"/>
+            <a:off x="2438247" y="512064"/>
+            <a:ext cx="7315200" cy="420624"/>
           </a:xfrm>
           <a:prstGeom prst="rect">
             <a:avLst/>
@@ -7319,7 +7442,7 @@
               </a:lnSpc>
             </a:pPr>
             <a:r>
-              <a:rPr sz="1855" b="1" i="0" spc="420">
+              <a:rPr sz="2088" b="1" i="0" spc="420">
                 <a:solidFill>
                   <a:srgbClr val="C18150"/>
                 </a:solidFill>
@@ -7338,13 +7461,13 @@
         </p:nvCxnSpPr>
         <p:spPr>
           <a:xfrm>
-            <a:off x="5730087" y="1024128"/>
-            <a:ext cx="731520" cy="0"/>
+            <a:off x="5684367" y="1042415"/>
+            <a:ext cx="822960" cy="0"/>
           </a:xfrm>
           <a:prstGeom prst="bentConnector3">
             <a:avLst/>
           </a:prstGeom>
-          <a:ln w="30480">
+          <a:ln w="33020">
             <a:solidFill>
               <a:srgbClr val="C18150"/>
             </a:solidFill>
@@ -8333,7 +8456,7 @@
         </p:nvSpPr>
         <p:spPr>
           <a:xfrm>
-            <a:off x="335127" y="4572000"/>
+            <a:off x="335127" y="4553712"/>
             <a:ext cx="11521440" cy="548640"/>
           </a:xfrm>
           <a:prstGeom prst="rect">
@@ -8353,7 +8476,7 @@
               </a:lnSpc>
             </a:pPr>
             <a:r>
-              <a:rPr sz="3015" b="1" i="0">
+              <a:rPr sz="3247" b="1" i="0">
                 <a:solidFill>
                   <a:srgbClr val="3E2C1E"/>
                 </a:solidFill>
@@ -9249,8 +9372,8 @@
         </p:nvSpPr>
         <p:spPr>
           <a:xfrm>
-            <a:off x="2438247" y="530352"/>
-            <a:ext cx="7315200" cy="402336"/>
+            <a:off x="2438247" y="512064"/>
+            <a:ext cx="7315200" cy="420624"/>
           </a:xfrm>
           <a:prstGeom prst="rect">
             <a:avLst/>
@@ -9269,7 +9392,7 @@
               </a:lnSpc>
             </a:pPr>
             <a:r>
-              <a:rPr sz="1855" b="1" i="0" spc="420">
+              <a:rPr sz="2088" b="1" i="0" spc="420">
                 <a:solidFill>
                   <a:srgbClr val="CE5A38"/>
                 </a:solidFill>
@@ -9288,13 +9411,13 @@
         </p:nvCxnSpPr>
         <p:spPr>
           <a:xfrm>
-            <a:off x="5730087" y="1024128"/>
-            <a:ext cx="731520" cy="0"/>
+            <a:off x="5684367" y="1042415"/>
+            <a:ext cx="822960" cy="0"/>
           </a:xfrm>
           <a:prstGeom prst="bentConnector3">
             <a:avLst/>
           </a:prstGeom>
-          <a:ln w="30480">
+          <a:ln w="33020">
             <a:solidFill>
               <a:srgbClr val="CE5A38"/>
             </a:solidFill>
@@ -10433,7 +10556,7 @@
               </a:lnSpc>
             </a:pPr>
             <a:r>
-              <a:rPr sz="3015" b="1" i="0">
+              <a:rPr sz="3247" b="1" i="0">
                 <a:solidFill>
                   <a:srgbClr val="3E2C1E"/>
                 </a:solidFill>
@@ -10442,7 +10565,7 @@
               <a:t>Female names scored </a:t>
             </a:r>
             <a:r>
-              <a:rPr sz="3015" b="1" i="0">
+              <a:rPr sz="3247" b="1" i="0">
                 <a:solidFill>
                   <a:srgbClr val="E96CA4"/>
                 </a:solidFill>
@@ -10451,7 +10574,7 @@
               <a:t>slightly higher</a:t>
             </a:r>
             <a:r>
-              <a:rPr sz="3015" b="1" i="0">
+              <a:rPr sz="3247" b="1" i="0">
                 <a:solidFill>
                   <a:srgbClr val="3E2C1E"/>
                 </a:solidFill>
@@ -10623,8 +10746,8 @@
         </p:nvSpPr>
         <p:spPr>
           <a:xfrm>
-            <a:off x="2438247" y="530352"/>
-            <a:ext cx="7315200" cy="402336"/>
+            <a:off x="2438247" y="512064"/>
+            <a:ext cx="7315200" cy="420624"/>
           </a:xfrm>
           <a:prstGeom prst="rect">
             <a:avLst/>
@@ -10643,7 +10766,7 @@
               </a:lnSpc>
             </a:pPr>
             <a:r>
-              <a:rPr sz="1855" b="1" i="0" spc="420">
+              <a:rPr sz="2088" b="1" i="0" spc="420">
                 <a:solidFill>
                   <a:srgbClr val="DCA62A"/>
                 </a:solidFill>
@@ -10662,13 +10785,13 @@
         </p:nvCxnSpPr>
         <p:spPr>
           <a:xfrm>
-            <a:off x="5730087" y="1024128"/>
-            <a:ext cx="731520" cy="0"/>
+            <a:off x="5684367" y="1042415"/>
+            <a:ext cx="822960" cy="0"/>
           </a:xfrm>
           <a:prstGeom prst="bentConnector3">
             <a:avLst/>
           </a:prstGeom>
-          <a:ln w="30480">
+          <a:ln w="33020">
             <a:solidFill>
               <a:srgbClr val="DCA62A"/>
             </a:solidFill>
@@ -11594,7 +11717,7 @@
               </a:lnSpc>
             </a:pPr>
             <a:r>
-              <a:rPr sz="3247" b="1" i="0">
+              <a:rPr sz="3596" b="1" i="0">
                 <a:solidFill>
                   <a:srgbClr val="3E2C1E"/>
                 </a:solidFill>
@@ -11766,8 +11889,8 @@
         </p:nvSpPr>
         <p:spPr>
           <a:xfrm>
-            <a:off x="2438247" y="530352"/>
-            <a:ext cx="7315200" cy="402336"/>
+            <a:off x="2438247" y="512064"/>
+            <a:ext cx="7315200" cy="420624"/>
           </a:xfrm>
           <a:prstGeom prst="rect">
             <a:avLst/>
@@ -11786,7 +11909,7 @@
               </a:lnSpc>
             </a:pPr>
             <a:r>
-              <a:rPr sz="1855" b="1" i="0" spc="420">
+              <a:rPr sz="2088" b="1" i="0" spc="420">
                 <a:solidFill>
                   <a:srgbClr val="C18150"/>
                 </a:solidFill>
@@ -11805,13 +11928,13 @@
         </p:nvCxnSpPr>
         <p:spPr>
           <a:xfrm>
-            <a:off x="5730087" y="1024128"/>
-            <a:ext cx="731520" cy="0"/>
+            <a:off x="5684367" y="1042415"/>
+            <a:ext cx="822960" cy="0"/>
           </a:xfrm>
           <a:prstGeom prst="bentConnector3">
             <a:avLst/>
           </a:prstGeom>
-          <a:ln w="30480">
+          <a:ln w="33020">
             <a:solidFill>
               <a:srgbClr val="C18150"/>
             </a:solidFill>
@@ -12237,8 +12360,8 @@
         </p:nvSpPr>
         <p:spPr>
           <a:xfrm>
-            <a:off x="518007" y="5166360"/>
-            <a:ext cx="11155680" cy="1234440"/>
+            <a:off x="518007" y="5120640"/>
+            <a:ext cx="11155680" cy="1280160"/>
           </a:xfrm>
           <a:prstGeom prst="rect">
             <a:avLst/>
@@ -12257,7 +12380,7 @@
               </a:lnSpc>
             </a:pPr>
             <a:r>
-              <a:rPr sz="3131" b="1" i="0">
+              <a:rPr sz="3479" b="1" i="0">
                 <a:solidFill>
                   <a:srgbClr val="3E2C1E"/>
                 </a:solidFill>
@@ -12273,7 +12396,7 @@
               </a:lnSpc>
             </a:pPr>
             <a:r>
-              <a:rPr sz="3131" b="1" i="0">
+              <a:rPr sz="3479" b="1" i="0">
                 <a:solidFill>
                   <a:srgbClr val="3E2C1E"/>
                 </a:solidFill>
@@ -12445,8 +12568,8 @@
         </p:nvSpPr>
         <p:spPr>
           <a:xfrm>
-            <a:off x="2438247" y="530352"/>
-            <a:ext cx="7315200" cy="402336"/>
+            <a:off x="2438247" y="512064"/>
+            <a:ext cx="7315200" cy="420624"/>
           </a:xfrm>
           <a:prstGeom prst="rect">
             <a:avLst/>
@@ -12465,7 +12588,7 @@
               </a:lnSpc>
             </a:pPr>
             <a:r>
-              <a:rPr sz="1855" b="1" i="0" spc="420">
+              <a:rPr sz="2088" b="1" i="0" spc="420">
                 <a:solidFill>
                   <a:srgbClr val="C18150"/>
                 </a:solidFill>
@@ -12484,13 +12607,13 @@
         </p:nvCxnSpPr>
         <p:spPr>
           <a:xfrm>
-            <a:off x="5730087" y="1024128"/>
-            <a:ext cx="731520" cy="0"/>
+            <a:off x="5684367" y="1042415"/>
+            <a:ext cx="822960" cy="0"/>
           </a:xfrm>
           <a:prstGeom prst="bentConnector3">
             <a:avLst/>
           </a:prstGeom>
-          <a:ln w="30480">
+          <a:ln w="33020">
             <a:solidFill>
               <a:srgbClr val="C18150"/>
             </a:solidFill>
@@ -12520,8 +12643,8 @@
         </p:nvSpPr>
         <p:spPr>
           <a:xfrm>
-            <a:off x="335127" y="2194560"/>
-            <a:ext cx="11521440" cy="2103120"/>
+            <a:off x="335127" y="2148840"/>
+            <a:ext cx="11521440" cy="2148840"/>
           </a:xfrm>
           <a:prstGeom prst="rect">
             <a:avLst/>
@@ -12540,7 +12663,7 @@
               </a:lnSpc>
             </a:pPr>
             <a:r>
-              <a:rPr sz="4291" b="1" i="0">
+              <a:rPr sz="4755" b="1" i="0">
                 <a:solidFill>
                   <a:srgbClr val="3E2C1E"/>
                 </a:solidFill>
@@ -12556,7 +12679,7 @@
               </a:lnSpc>
             </a:pPr>
             <a:r>
-              <a:rPr sz="4291" b="1" i="0">
+              <a:rPr sz="4755" b="1" i="0">
                 <a:solidFill>
                   <a:srgbClr val="3E2C1E"/>
                 </a:solidFill>
@@ -12565,7 +12688,7 @@
               <a:t/>
             </a:r>
             <a:r>
-              <a:rPr sz="4291" b="1" i="0">
+              <a:rPr sz="4755" b="1" i="0">
                 <a:solidFill>
                   <a:srgbClr val="CE5A38"/>
                 </a:solidFill>
@@ -12584,7 +12707,7 @@
         </p:nvSpPr>
         <p:spPr>
           <a:xfrm>
-            <a:off x="883767" y="4937760"/>
+            <a:off x="883767" y="5029200"/>
             <a:ext cx="10424160" cy="640080"/>
           </a:xfrm>
           <a:prstGeom prst="rect">
@@ -12604,7 +12727,7 @@
               </a:lnSpc>
             </a:pPr>
             <a:r>
-              <a:rPr sz="2668" b="1" i="1">
+              <a:rPr sz="2783" b="1" i="1">
                 <a:solidFill>
                   <a:srgbClr val="C18150"/>
                 </a:solidFill>

</xml_diff>